<commit_message>
refactor(structure): reorganize deliverables, battlecards, one-pagers, and update presentation assets
</commit_message>
<xml_diff>
--- a/product-marketing-strategy.pptx
+++ b/product-marketing-strategy.pptx
@@ -164,2700 +164,6 @@
     <p1510:client id="{F36EC058-8456-4027-AD90-4B617BF2E8E0}" v="17" dt="2026-08-15T06:55:59.275"/>
   </p1510:revLst>
 </p1510:revInfo>
-</file>
-
-<file path=ppt/changesInfos/changesInfo1.xml><?xml version="1.0" encoding="utf-8"?>
-<pc:chgInfo xmlns:a="http://schemas.openxmlformats.org/drawingml/2006/main" xmlns:r="http://schemas.openxmlformats.org/officeDocument/2006/relationships" xmlns:ac="http://schemas.microsoft.com/office/drawing/2013/main/command" xmlns:pc="http://schemas.microsoft.com/office/powerpoint/2013/main/command">
-  <pc:docChgLst>
-    <pc:chgData name="Shivam Singh" userId="e52e9ba4b5bcdf08" providerId="LiveId" clId="{341AFF7A-C5CD-4491-9020-97A9030EB6ED}"/>
-    <pc:docChg chg="undo custSel addSld delSld modSld sldOrd modNotesMaster">
-      <pc:chgData name="Shivam Singh" userId="e52e9ba4b5bcdf08" providerId="LiveId" clId="{341AFF7A-C5CD-4491-9020-97A9030EB6ED}" dt="2026-08-15T06:56:18.102" v="223"/>
-      <pc:docMkLst>
-        <pc:docMk/>
-      </pc:docMkLst>
-      <pc:sldChg chg="addSp delSp modSp del mod">
-        <pc:chgData name="Shivam Singh" userId="e52e9ba4b5bcdf08" providerId="LiveId" clId="{341AFF7A-C5CD-4491-9020-97A9030EB6ED}" dt="2026-08-15T06:41:07.439" v="79" actId="2696"/>
-        <pc:sldMkLst>
-          <pc:docMk/>
-          <pc:sldMk cId="0" sldId="256"/>
-        </pc:sldMkLst>
-        <pc:spChg chg="mod">
-          <ac:chgData name="Shivam Singh" userId="e52e9ba4b5bcdf08" providerId="LiveId" clId="{341AFF7A-C5CD-4491-9020-97A9030EB6ED}" dt="2026-08-15T06:31:48.831" v="1" actId="26606"/>
-          <ac:spMkLst>
-            <pc:docMk/>
-            <pc:sldMk cId="0" sldId="256"/>
-            <ac:spMk id="3" creationId="{00000000-0000-0000-0000-000000000000}"/>
-          </ac:spMkLst>
-        </pc:spChg>
-        <pc:spChg chg="mod">
-          <ac:chgData name="Shivam Singh" userId="e52e9ba4b5bcdf08" providerId="LiveId" clId="{341AFF7A-C5CD-4491-9020-97A9030EB6ED}" dt="2026-08-15T06:31:48.831" v="1" actId="26606"/>
-          <ac:spMkLst>
-            <pc:docMk/>
-            <pc:sldMk cId="0" sldId="256"/>
-            <ac:spMk id="8" creationId="{00000000-0000-0000-0000-000000000000}"/>
-          </ac:spMkLst>
-        </pc:spChg>
-        <pc:spChg chg="mod">
-          <ac:chgData name="Shivam Singh" userId="e52e9ba4b5bcdf08" providerId="LiveId" clId="{341AFF7A-C5CD-4491-9020-97A9030EB6ED}" dt="2026-08-15T06:31:48.831" v="1" actId="26606"/>
-          <ac:spMkLst>
-            <pc:docMk/>
-            <pc:sldMk cId="0" sldId="256"/>
-            <ac:spMk id="11" creationId="{00000000-0000-0000-0000-000000000000}"/>
-          </ac:spMkLst>
-        </pc:spChg>
-        <pc:spChg chg="mod">
-          <ac:chgData name="Shivam Singh" userId="e52e9ba4b5bcdf08" providerId="LiveId" clId="{341AFF7A-C5CD-4491-9020-97A9030EB6ED}" dt="2026-08-15T06:31:48.831" v="1" actId="26606"/>
-          <ac:spMkLst>
-            <pc:docMk/>
-            <pc:sldMk cId="0" sldId="256"/>
-            <ac:spMk id="15" creationId="{00000000-0000-0000-0000-000000000000}"/>
-          </ac:spMkLst>
-        </pc:spChg>
-        <pc:spChg chg="mod">
-          <ac:chgData name="Shivam Singh" userId="e52e9ba4b5bcdf08" providerId="LiveId" clId="{341AFF7A-C5CD-4491-9020-97A9030EB6ED}" dt="2026-08-15T06:31:48.831" v="1" actId="26606"/>
-          <ac:spMkLst>
-            <pc:docMk/>
-            <pc:sldMk cId="0" sldId="256"/>
-            <ac:spMk id="16" creationId="{00000000-0000-0000-0000-000000000000}"/>
-          </ac:spMkLst>
-        </pc:spChg>
-        <pc:spChg chg="mod">
-          <ac:chgData name="Shivam Singh" userId="e52e9ba4b5bcdf08" providerId="LiveId" clId="{341AFF7A-C5CD-4491-9020-97A9030EB6ED}" dt="2026-08-15T06:31:48.831" v="1" actId="26606"/>
-          <ac:spMkLst>
-            <pc:docMk/>
-            <pc:sldMk cId="0" sldId="256"/>
-            <ac:spMk id="27" creationId="{00000000-0000-0000-0000-000000000000}"/>
-          </ac:spMkLst>
-        </pc:spChg>
-        <pc:spChg chg="del">
-          <ac:chgData name="Shivam Singh" userId="e52e9ba4b5bcdf08" providerId="LiveId" clId="{341AFF7A-C5CD-4491-9020-97A9030EB6ED}" dt="2026-08-15T06:31:48.831" v="1" actId="26606"/>
-          <ac:spMkLst>
-            <pc:docMk/>
-            <pc:sldMk cId="0" sldId="256"/>
-            <ac:spMk id="41" creationId="{00000000-0000-0000-0000-000000000000}"/>
-          </ac:spMkLst>
-        </pc:spChg>
-        <pc:spChg chg="del">
-          <ac:chgData name="Shivam Singh" userId="e52e9ba4b5bcdf08" providerId="LiveId" clId="{341AFF7A-C5CD-4491-9020-97A9030EB6ED}" dt="2026-08-15T06:31:48.831" v="1" actId="26606"/>
-          <ac:spMkLst>
-            <pc:docMk/>
-            <pc:sldMk cId="0" sldId="256"/>
-            <ac:spMk id="44" creationId="{00000000-0000-0000-0000-000000000000}"/>
-          </ac:spMkLst>
-        </pc:spChg>
-        <pc:spChg chg="del">
-          <ac:chgData name="Shivam Singh" userId="e52e9ba4b5bcdf08" providerId="LiveId" clId="{341AFF7A-C5CD-4491-9020-97A9030EB6ED}" dt="2026-08-15T06:31:48.831" v="1" actId="26606"/>
-          <ac:spMkLst>
-            <pc:docMk/>
-            <pc:sldMk cId="0" sldId="256"/>
-            <ac:spMk id="46" creationId="{00000000-0000-0000-0000-000000000000}"/>
-          </ac:spMkLst>
-        </pc:spChg>
-        <pc:spChg chg="del mod replId">
-          <ac:chgData name="Shivam Singh" userId="e52e9ba4b5bcdf08" providerId="LiveId" clId="{341AFF7A-C5CD-4491-9020-97A9030EB6ED}" dt="2026-08-15T06:31:48.831" v="1" actId="26606"/>
-          <ac:spMkLst>
-            <pc:docMk/>
-            <pc:sldMk cId="0" sldId="256"/>
-            <ac:spMk id="51" creationId="{00000000-0000-0000-0000-000000000000}"/>
-          </ac:spMkLst>
-        </pc:spChg>
-        <pc:spChg chg="mod replId">
-          <ac:chgData name="Shivam Singh" userId="e52e9ba4b5bcdf08" providerId="LiveId" clId="{341AFF7A-C5CD-4491-9020-97A9030EB6ED}" dt="2026-08-15T06:31:47.763" v="0" actId="26606"/>
-          <ac:spMkLst>
-            <pc:docMk/>
-            <pc:sldMk cId="0" sldId="256"/>
-            <ac:spMk id="52" creationId="{00000000-0000-0000-0000-000000000000}"/>
-          </ac:spMkLst>
-        </pc:spChg>
-        <pc:spChg chg="mod replId">
-          <ac:chgData name="Shivam Singh" userId="e52e9ba4b5bcdf08" providerId="LiveId" clId="{341AFF7A-C5CD-4491-9020-97A9030EB6ED}" dt="2026-08-15T06:31:47.763" v="0" actId="26606"/>
-          <ac:spMkLst>
-            <pc:docMk/>
-            <pc:sldMk cId="0" sldId="256"/>
-            <ac:spMk id="53" creationId="{00000000-0000-0000-0000-000000000000}"/>
-          </ac:spMkLst>
-        </pc:spChg>
-        <pc:spChg chg="mod replId">
-          <ac:chgData name="Shivam Singh" userId="e52e9ba4b5bcdf08" providerId="LiveId" clId="{341AFF7A-C5CD-4491-9020-97A9030EB6ED}" dt="2026-08-15T06:31:47.763" v="0" actId="26606"/>
-          <ac:spMkLst>
-            <pc:docMk/>
-            <pc:sldMk cId="0" sldId="256"/>
-            <ac:spMk id="54" creationId="{00000000-0000-0000-0000-000000000000}"/>
-          </ac:spMkLst>
-        </pc:spChg>
-        <pc:spChg chg="mod replId">
-          <ac:chgData name="Shivam Singh" userId="e52e9ba4b5bcdf08" providerId="LiveId" clId="{341AFF7A-C5CD-4491-9020-97A9030EB6ED}" dt="2026-08-15T06:31:47.763" v="0" actId="26606"/>
-          <ac:spMkLst>
-            <pc:docMk/>
-            <pc:sldMk cId="0" sldId="256"/>
-            <ac:spMk id="55" creationId="{00000000-0000-0000-0000-000000000000}"/>
-          </ac:spMkLst>
-        </pc:spChg>
-        <pc:spChg chg="mod replId">
-          <ac:chgData name="Shivam Singh" userId="e52e9ba4b5bcdf08" providerId="LiveId" clId="{341AFF7A-C5CD-4491-9020-97A9030EB6ED}" dt="2026-08-15T06:31:47.763" v="0" actId="26606"/>
-          <ac:spMkLst>
-            <pc:docMk/>
-            <pc:sldMk cId="0" sldId="256"/>
-            <ac:spMk id="56" creationId="{00000000-0000-0000-0000-000000000000}"/>
-          </ac:spMkLst>
-        </pc:spChg>
-        <pc:spChg chg="mod replId">
-          <ac:chgData name="Shivam Singh" userId="e52e9ba4b5bcdf08" providerId="LiveId" clId="{341AFF7A-C5CD-4491-9020-97A9030EB6ED}" dt="2026-08-15T06:31:47.763" v="0" actId="26606"/>
-          <ac:spMkLst>
-            <pc:docMk/>
-            <pc:sldMk cId="0" sldId="256"/>
-            <ac:spMk id="57" creationId="{00000000-0000-0000-0000-000000000000}"/>
-          </ac:spMkLst>
-        </pc:spChg>
-        <pc:spChg chg="mod replId">
-          <ac:chgData name="Shivam Singh" userId="e52e9ba4b5bcdf08" providerId="LiveId" clId="{341AFF7A-C5CD-4491-9020-97A9030EB6ED}" dt="2026-08-15T06:31:47.763" v="0" actId="26606"/>
-          <ac:spMkLst>
-            <pc:docMk/>
-            <pc:sldMk cId="0" sldId="256"/>
-            <ac:spMk id="58" creationId="{00000000-0000-0000-0000-000000000000}"/>
-          </ac:spMkLst>
-        </pc:spChg>
-        <pc:picChg chg="mod replId">
-          <ac:chgData name="Shivam Singh" userId="e52e9ba4b5bcdf08" providerId="LiveId" clId="{341AFF7A-C5CD-4491-9020-97A9030EB6ED}" dt="2026-08-15T06:31:47.763" v="0" actId="26606"/>
-          <ac:picMkLst>
-            <pc:docMk/>
-            <pc:sldMk cId="0" sldId="256"/>
-            <ac:picMk id="50" creationId="{00000000-0000-0000-0000-000000000000}"/>
-          </ac:picMkLst>
-        </pc:picChg>
-      </pc:sldChg>
-      <pc:sldChg chg="modSp add mod">
-        <pc:chgData name="Shivam Singh" userId="e52e9ba4b5bcdf08" providerId="LiveId" clId="{341AFF7A-C5CD-4491-9020-97A9030EB6ED}" dt="2026-08-15T06:52:05.400" v="139" actId="26606"/>
-        <pc:sldMkLst>
-          <pc:docMk/>
-          <pc:sldMk cId="712490143" sldId="256"/>
-        </pc:sldMkLst>
-        <pc:spChg chg="mod">
-          <ac:chgData name="Shivam Singh" userId="e52e9ba4b5bcdf08" providerId="LiveId" clId="{341AFF7A-C5CD-4491-9020-97A9030EB6ED}" dt="2026-08-15T06:52:05.400" v="139" actId="26606"/>
-          <ac:spMkLst>
-            <pc:docMk/>
-            <pc:sldMk cId="712490143" sldId="256"/>
-            <ac:spMk id="31" creationId="{0C7BEF25-A2E2-6855-15D7-7A9197997596}"/>
-          </ac:spMkLst>
-        </pc:spChg>
-        <pc:spChg chg="mod">
-          <ac:chgData name="Shivam Singh" userId="e52e9ba4b5bcdf08" providerId="LiveId" clId="{341AFF7A-C5CD-4491-9020-97A9030EB6ED}" dt="2026-08-15T06:52:05.400" v="139" actId="26606"/>
-          <ac:spMkLst>
-            <pc:docMk/>
-            <pc:sldMk cId="712490143" sldId="256"/>
-            <ac:spMk id="32" creationId="{85B66BF0-1952-CF0D-6E5A-708E999447AB}"/>
-          </ac:spMkLst>
-        </pc:spChg>
-      </pc:sldChg>
-      <pc:sldChg chg="add del setBg">
-        <pc:chgData name="Shivam Singh" userId="e52e9ba4b5bcdf08" providerId="LiveId" clId="{341AFF7A-C5CD-4491-9020-97A9030EB6ED}" dt="2026-08-15T06:41:22.616" v="83"/>
-        <pc:sldMkLst>
-          <pc:docMk/>
-          <pc:sldMk cId="1842778677" sldId="256"/>
-        </pc:sldMkLst>
-      </pc:sldChg>
-      <pc:sldChg chg="add del setBg">
-        <pc:chgData name="Shivam Singh" userId="e52e9ba4b5bcdf08" providerId="LiveId" clId="{341AFF7A-C5CD-4491-9020-97A9030EB6ED}" dt="2026-08-15T06:41:18.800" v="81"/>
-        <pc:sldMkLst>
-          <pc:docMk/>
-          <pc:sldMk cId="2166946978" sldId="256"/>
-        </pc:sldMkLst>
-      </pc:sldChg>
-      <pc:sldChg chg="addSp delSp modSp mod ord">
-        <pc:chgData name="Shivam Singh" userId="e52e9ba4b5bcdf08" providerId="LiveId" clId="{341AFF7A-C5CD-4491-9020-97A9030EB6ED}" dt="2026-08-15T06:56:18.102" v="223"/>
-        <pc:sldMkLst>
-          <pc:docMk/>
-          <pc:sldMk cId="0" sldId="257"/>
-        </pc:sldMkLst>
-        <pc:spChg chg="mod">
-          <ac:chgData name="Shivam Singh" userId="e52e9ba4b5bcdf08" providerId="LiveId" clId="{341AFF7A-C5CD-4491-9020-97A9030EB6ED}" dt="2026-08-15T06:55:35.246" v="219" actId="20577"/>
-          <ac:spMkLst>
-            <pc:docMk/>
-            <pc:sldMk cId="0" sldId="257"/>
-            <ac:spMk id="2" creationId="{00000000-0000-0000-0000-000000000000}"/>
-          </ac:spMkLst>
-        </pc:spChg>
-        <pc:spChg chg="mod">
-          <ac:chgData name="Shivam Singh" userId="e52e9ba4b5bcdf08" providerId="LiveId" clId="{341AFF7A-C5CD-4491-9020-97A9030EB6ED}" dt="2026-08-15T06:55:59.275" v="220"/>
-          <ac:spMkLst>
-            <pc:docMk/>
-            <pc:sldMk cId="0" sldId="257"/>
-            <ac:spMk id="3" creationId="{00000000-0000-0000-0000-000000000000}"/>
-          </ac:spMkLst>
-        </pc:spChg>
-        <pc:spChg chg="mod">
-          <ac:chgData name="Shivam Singh" userId="e52e9ba4b5bcdf08" providerId="LiveId" clId="{341AFF7A-C5CD-4491-9020-97A9030EB6ED}" dt="2026-08-15T06:52:05.400" v="139" actId="26606"/>
-          <ac:spMkLst>
-            <pc:docMk/>
-            <pc:sldMk cId="0" sldId="257"/>
-            <ac:spMk id="8" creationId="{00000000-0000-0000-0000-000000000000}"/>
-          </ac:spMkLst>
-        </pc:spChg>
-        <pc:spChg chg="mod">
-          <ac:chgData name="Shivam Singh" userId="e52e9ba4b5bcdf08" providerId="LiveId" clId="{341AFF7A-C5CD-4491-9020-97A9030EB6ED}" dt="2026-08-15T06:31:48.831" v="1" actId="26606"/>
-          <ac:spMkLst>
-            <pc:docMk/>
-            <pc:sldMk cId="0" sldId="257"/>
-            <ac:spMk id="9" creationId="{00000000-0000-0000-0000-000000000000}"/>
-          </ac:spMkLst>
-        </pc:spChg>
-        <pc:spChg chg="mod">
-          <ac:chgData name="Shivam Singh" userId="e52e9ba4b5bcdf08" providerId="LiveId" clId="{341AFF7A-C5CD-4491-9020-97A9030EB6ED}" dt="2026-08-15T06:31:48.831" v="1" actId="26606"/>
-          <ac:spMkLst>
-            <pc:docMk/>
-            <pc:sldMk cId="0" sldId="257"/>
-            <ac:spMk id="10" creationId="{00000000-0000-0000-0000-000000000000}"/>
-          </ac:spMkLst>
-        </pc:spChg>
-        <pc:spChg chg="mod">
-          <ac:chgData name="Shivam Singh" userId="e52e9ba4b5bcdf08" providerId="LiveId" clId="{341AFF7A-C5CD-4491-9020-97A9030EB6ED}" dt="2026-08-15T06:52:05.400" v="139" actId="26606"/>
-          <ac:spMkLst>
-            <pc:docMk/>
-            <pc:sldMk cId="0" sldId="257"/>
-            <ac:spMk id="11" creationId="{00000000-0000-0000-0000-000000000000}"/>
-          </ac:spMkLst>
-        </pc:spChg>
-        <pc:spChg chg="mod">
-          <ac:chgData name="Shivam Singh" userId="e52e9ba4b5bcdf08" providerId="LiveId" clId="{341AFF7A-C5CD-4491-9020-97A9030EB6ED}" dt="2026-08-15T06:52:05.400" v="139" actId="26606"/>
-          <ac:spMkLst>
-            <pc:docMk/>
-            <pc:sldMk cId="0" sldId="257"/>
-            <ac:spMk id="14" creationId="{00000000-0000-0000-0000-000000000000}"/>
-          </ac:spMkLst>
-        </pc:spChg>
-        <pc:spChg chg="mod">
-          <ac:chgData name="Shivam Singh" userId="e52e9ba4b5bcdf08" providerId="LiveId" clId="{341AFF7A-C5CD-4491-9020-97A9030EB6ED}" dt="2026-08-15T06:31:48.831" v="1" actId="26606"/>
-          <ac:spMkLst>
-            <pc:docMk/>
-            <pc:sldMk cId="0" sldId="257"/>
-            <ac:spMk id="15" creationId="{00000000-0000-0000-0000-000000000000}"/>
-          </ac:spMkLst>
-        </pc:spChg>
-        <pc:spChg chg="mod">
-          <ac:chgData name="Shivam Singh" userId="e52e9ba4b5bcdf08" providerId="LiveId" clId="{341AFF7A-C5CD-4491-9020-97A9030EB6ED}" dt="2026-08-15T06:52:05.400" v="139" actId="26606"/>
-          <ac:spMkLst>
-            <pc:docMk/>
-            <pc:sldMk cId="0" sldId="257"/>
-            <ac:spMk id="17" creationId="{00000000-0000-0000-0000-000000000000}"/>
-          </ac:spMkLst>
-        </pc:spChg>
-        <pc:spChg chg="mod">
-          <ac:chgData name="Shivam Singh" userId="e52e9ba4b5bcdf08" providerId="LiveId" clId="{341AFF7A-C5CD-4491-9020-97A9030EB6ED}" dt="2026-08-15T06:52:05.400" v="139" actId="26606"/>
-          <ac:spMkLst>
-            <pc:docMk/>
-            <pc:sldMk cId="0" sldId="257"/>
-            <ac:spMk id="20" creationId="{00000000-0000-0000-0000-000000000000}"/>
-          </ac:spMkLst>
-        </pc:spChg>
-        <pc:spChg chg="mod">
-          <ac:chgData name="Shivam Singh" userId="e52e9ba4b5bcdf08" providerId="LiveId" clId="{341AFF7A-C5CD-4491-9020-97A9030EB6ED}" dt="2026-08-15T06:52:05.400" v="139" actId="26606"/>
-          <ac:spMkLst>
-            <pc:docMk/>
-            <pc:sldMk cId="0" sldId="257"/>
-            <ac:spMk id="23" creationId="{00000000-0000-0000-0000-000000000000}"/>
-          </ac:spMkLst>
-        </pc:spChg>
-        <pc:spChg chg="del">
-          <ac:chgData name="Shivam Singh" userId="e52e9ba4b5bcdf08" providerId="LiveId" clId="{341AFF7A-C5CD-4491-9020-97A9030EB6ED}" dt="2026-08-15T06:53:04.041" v="153" actId="478"/>
-          <ac:spMkLst>
-            <pc:docMk/>
-            <pc:sldMk cId="0" sldId="257"/>
-            <ac:spMk id="25" creationId="{00000000-0000-0000-0000-000000000000}"/>
-          </ac:spMkLst>
-        </pc:spChg>
-        <pc:spChg chg="del mod">
-          <ac:chgData name="Shivam Singh" userId="e52e9ba4b5bcdf08" providerId="LiveId" clId="{341AFF7A-C5CD-4491-9020-97A9030EB6ED}" dt="2026-08-15T06:54:52.202" v="182" actId="478"/>
-          <ac:spMkLst>
-            <pc:docMk/>
-            <pc:sldMk cId="0" sldId="257"/>
-            <ac:spMk id="27" creationId="{00000000-0000-0000-0000-000000000000}"/>
-          </ac:spMkLst>
-        </pc:spChg>
-        <pc:spChg chg="del mod">
-          <ac:chgData name="Shivam Singh" userId="e52e9ba4b5bcdf08" providerId="LiveId" clId="{341AFF7A-C5CD-4491-9020-97A9030EB6ED}" dt="2026-08-15T06:54:50.402" v="180" actId="478"/>
-          <ac:spMkLst>
-            <pc:docMk/>
-            <pc:sldMk cId="0" sldId="257"/>
-            <ac:spMk id="28" creationId="{00000000-0000-0000-0000-000000000000}"/>
-          </ac:spMkLst>
-        </pc:spChg>
-        <pc:spChg chg="del mod">
-          <ac:chgData name="Shivam Singh" userId="e52e9ba4b5bcdf08" providerId="LiveId" clId="{341AFF7A-C5CD-4491-9020-97A9030EB6ED}" dt="2026-08-15T06:54:58.862" v="186" actId="478"/>
-          <ac:spMkLst>
-            <pc:docMk/>
-            <pc:sldMk cId="0" sldId="257"/>
-            <ac:spMk id="29" creationId="{00000000-0000-0000-0000-000000000000}"/>
-          </ac:spMkLst>
-        </pc:spChg>
-        <pc:spChg chg="mod">
-          <ac:chgData name="Shivam Singh" userId="e52e9ba4b5bcdf08" providerId="LiveId" clId="{341AFF7A-C5CD-4491-9020-97A9030EB6ED}" dt="2026-08-15T06:52:05.400" v="139" actId="26606"/>
-          <ac:spMkLst>
-            <pc:docMk/>
-            <pc:sldMk cId="0" sldId="257"/>
-            <ac:spMk id="30" creationId="{00000000-0000-0000-0000-000000000000}"/>
-          </ac:spMkLst>
-        </pc:spChg>
-        <pc:spChg chg="mod">
-          <ac:chgData name="Shivam Singh" userId="e52e9ba4b5bcdf08" providerId="LiveId" clId="{341AFF7A-C5CD-4491-9020-97A9030EB6ED}" dt="2026-08-15T06:52:05.400" v="139" actId="26606"/>
-          <ac:spMkLst>
-            <pc:docMk/>
-            <pc:sldMk cId="0" sldId="257"/>
-            <ac:spMk id="34" creationId="{00000000-0000-0000-0000-000000000000}"/>
-          </ac:spMkLst>
-        </pc:spChg>
-        <pc:spChg chg="del">
-          <ac:chgData name="Shivam Singh" userId="e52e9ba4b5bcdf08" providerId="LiveId" clId="{341AFF7A-C5CD-4491-9020-97A9030EB6ED}" dt="2026-08-15T06:31:48.831" v="1" actId="26606"/>
-          <ac:spMkLst>
-            <pc:docMk/>
-            <pc:sldMk cId="0" sldId="257"/>
-            <ac:spMk id="39" creationId="{00000000-0000-0000-0000-000000000000}"/>
-          </ac:spMkLst>
-        </pc:spChg>
-        <pc:spChg chg="del">
-          <ac:chgData name="Shivam Singh" userId="e52e9ba4b5bcdf08" providerId="LiveId" clId="{341AFF7A-C5CD-4491-9020-97A9030EB6ED}" dt="2026-08-15T06:31:48.831" v="1" actId="26606"/>
-          <ac:spMkLst>
-            <pc:docMk/>
-            <pc:sldMk cId="0" sldId="257"/>
-            <ac:spMk id="41" creationId="{00000000-0000-0000-0000-000000000000}"/>
-          </ac:spMkLst>
-        </pc:spChg>
-        <pc:spChg chg="del">
-          <ac:chgData name="Shivam Singh" userId="e52e9ba4b5bcdf08" providerId="LiveId" clId="{341AFF7A-C5CD-4491-9020-97A9030EB6ED}" dt="2026-08-15T06:31:48.831" v="1" actId="26606"/>
-          <ac:spMkLst>
-            <pc:docMk/>
-            <pc:sldMk cId="0" sldId="257"/>
-            <ac:spMk id="44" creationId="{00000000-0000-0000-0000-000000000000}"/>
-          </ac:spMkLst>
-        </pc:spChg>
-        <pc:spChg chg="mod replId">
-          <ac:chgData name="Shivam Singh" userId="e52e9ba4b5bcdf08" providerId="LiveId" clId="{341AFF7A-C5CD-4491-9020-97A9030EB6ED}" dt="2026-08-15T06:31:47.763" v="0" actId="26606"/>
-          <ac:spMkLst>
-            <pc:docMk/>
-            <pc:sldMk cId="0" sldId="257"/>
-            <ac:spMk id="48" creationId="{00000000-0000-0000-0000-000000000000}"/>
-          </ac:spMkLst>
-        </pc:spChg>
-        <pc:spChg chg="mod replId">
-          <ac:chgData name="Shivam Singh" userId="e52e9ba4b5bcdf08" providerId="LiveId" clId="{341AFF7A-C5CD-4491-9020-97A9030EB6ED}" dt="2026-08-15T06:31:47.763" v="0" actId="26606"/>
-          <ac:spMkLst>
-            <pc:docMk/>
-            <pc:sldMk cId="0" sldId="257"/>
-            <ac:spMk id="50" creationId="{00000000-0000-0000-0000-000000000000}"/>
-          </ac:spMkLst>
-        </pc:spChg>
-        <pc:spChg chg="del mod replId">
-          <ac:chgData name="Shivam Singh" userId="e52e9ba4b5bcdf08" providerId="LiveId" clId="{341AFF7A-C5CD-4491-9020-97A9030EB6ED}" dt="2026-08-15T06:31:48.831" v="1" actId="26606"/>
-          <ac:spMkLst>
-            <pc:docMk/>
-            <pc:sldMk cId="0" sldId="257"/>
-            <ac:spMk id="51" creationId="{00000000-0000-0000-0000-000000000000}"/>
-          </ac:spMkLst>
-        </pc:spChg>
-        <pc:spChg chg="add mod">
-          <ac:chgData name="Shivam Singh" userId="e52e9ba4b5bcdf08" providerId="LiveId" clId="{341AFF7A-C5CD-4491-9020-97A9030EB6ED}" dt="2026-08-15T06:54:45.167" v="178" actId="1076"/>
-          <ac:spMkLst>
-            <pc:docMk/>
-            <pc:sldMk cId="0" sldId="257"/>
-            <ac:spMk id="53" creationId="{00000000-0000-0000-0000-000000000000}"/>
-          </ac:spMkLst>
-        </pc:spChg>
-        <pc:spChg chg="add del mod">
-          <ac:chgData name="Shivam Singh" userId="e52e9ba4b5bcdf08" providerId="LiveId" clId="{341AFF7A-C5CD-4491-9020-97A9030EB6ED}" dt="2026-08-15T06:54:28.298" v="167" actId="478"/>
-          <ac:spMkLst>
-            <pc:docMk/>
-            <pc:sldMk cId="0" sldId="257"/>
-            <ac:spMk id="54" creationId="{00000000-0000-0000-0000-000000000000}"/>
-          </ac:spMkLst>
-        </pc:spChg>
-        <pc:spChg chg="add del mod">
-          <ac:chgData name="Shivam Singh" userId="e52e9ba4b5bcdf08" providerId="LiveId" clId="{341AFF7A-C5CD-4491-9020-97A9030EB6ED}" dt="2026-08-15T06:54:30.331" v="169" actId="478"/>
-          <ac:spMkLst>
-            <pc:docMk/>
-            <pc:sldMk cId="0" sldId="257"/>
-            <ac:spMk id="55" creationId="{00000000-0000-0000-0000-000000000000}"/>
-          </ac:spMkLst>
-        </pc:spChg>
-        <pc:spChg chg="add del mod">
-          <ac:chgData name="Shivam Singh" userId="e52e9ba4b5bcdf08" providerId="LiveId" clId="{341AFF7A-C5CD-4491-9020-97A9030EB6ED}" dt="2026-08-15T06:54:32.221" v="171" actId="478"/>
-          <ac:spMkLst>
-            <pc:docMk/>
-            <pc:sldMk cId="0" sldId="257"/>
-            <ac:spMk id="56" creationId="{00000000-0000-0000-0000-000000000000}"/>
-          </ac:spMkLst>
-        </pc:spChg>
-        <pc:spChg chg="del mod">
-          <ac:chgData name="Shivam Singh" userId="e52e9ba4b5bcdf08" providerId="LiveId" clId="{341AFF7A-C5CD-4491-9020-97A9030EB6ED}" dt="2026-08-15T06:54:36.219" v="175" actId="478"/>
-          <ac:spMkLst>
-            <pc:docMk/>
-            <pc:sldMk cId="0" sldId="257"/>
-            <ac:spMk id="57" creationId="{00000000-0000-0000-0000-000000000000}"/>
-          </ac:spMkLst>
-        </pc:spChg>
-        <pc:spChg chg="add del mod">
-          <ac:chgData name="Shivam Singh" userId="e52e9ba4b5bcdf08" providerId="LiveId" clId="{341AFF7A-C5CD-4491-9020-97A9030EB6ED}" dt="2026-08-15T06:54:37.667" v="177" actId="478"/>
-          <ac:spMkLst>
-            <pc:docMk/>
-            <pc:sldMk cId="0" sldId="257"/>
-            <ac:spMk id="58" creationId="{00000000-0000-0000-0000-000000000000}"/>
-          </ac:spMkLst>
-        </pc:spChg>
-        <pc:spChg chg="add del mod">
-          <ac:chgData name="Shivam Singh" userId="e52e9ba4b5bcdf08" providerId="LiveId" clId="{341AFF7A-C5CD-4491-9020-97A9030EB6ED}" dt="2026-08-15T06:54:34.321" v="173" actId="478"/>
-          <ac:spMkLst>
-            <pc:docMk/>
-            <pc:sldMk cId="0" sldId="257"/>
-            <ac:spMk id="59" creationId="{00000000-0000-0000-0000-000000000000}"/>
-          </ac:spMkLst>
-        </pc:spChg>
-        <pc:spChg chg="add mod">
-          <ac:chgData name="Shivam Singh" userId="e52e9ba4b5bcdf08" providerId="LiveId" clId="{341AFF7A-C5CD-4491-9020-97A9030EB6ED}" dt="2026-08-15T06:55:04.006" v="187" actId="1076"/>
-          <ac:spMkLst>
-            <pc:docMk/>
-            <pc:sldMk cId="0" sldId="257"/>
-            <ac:spMk id="60" creationId="{00000000-0000-0000-0000-000000000000}"/>
-          </ac:spMkLst>
-        </pc:spChg>
-        <pc:spChg chg="add mod">
-          <ac:chgData name="Shivam Singh" userId="e52e9ba4b5bcdf08" providerId="LiveId" clId="{341AFF7A-C5CD-4491-9020-97A9030EB6ED}" dt="2026-08-15T06:55:08.244" v="188" actId="1076"/>
-          <ac:spMkLst>
-            <pc:docMk/>
-            <pc:sldMk cId="0" sldId="257"/>
-            <ac:spMk id="61" creationId="{00000000-0000-0000-0000-000000000000}"/>
-          </ac:spMkLst>
-        </pc:spChg>
-        <pc:spChg chg="add mod">
-          <ac:chgData name="Shivam Singh" userId="e52e9ba4b5bcdf08" providerId="LiveId" clId="{341AFF7A-C5CD-4491-9020-97A9030EB6ED}" dt="2026-08-15T06:54:22.946" v="165" actId="1076"/>
-          <ac:spMkLst>
-            <pc:docMk/>
-            <pc:sldMk cId="0" sldId="257"/>
-            <ac:spMk id="63" creationId="{00000000-0000-0000-0000-000000000000}"/>
-          </ac:spMkLst>
-        </pc:spChg>
-        <pc:spChg chg="add mod">
-          <ac:chgData name="Shivam Singh" userId="e52e9ba4b5bcdf08" providerId="LiveId" clId="{341AFF7A-C5CD-4491-9020-97A9030EB6ED}" dt="2026-08-15T06:54:22.946" v="165" actId="1076"/>
-          <ac:spMkLst>
-            <pc:docMk/>
-            <pc:sldMk cId="0" sldId="257"/>
-            <ac:spMk id="64" creationId="{00000000-0000-0000-0000-000000000000}"/>
-          </ac:spMkLst>
-        </pc:spChg>
-        <pc:graphicFrameChg chg="add del">
-          <ac:chgData name="Shivam Singh" userId="e52e9ba4b5bcdf08" providerId="LiveId" clId="{341AFF7A-C5CD-4491-9020-97A9030EB6ED}" dt="2026-08-15T06:53:26.941" v="156" actId="478"/>
-          <ac:graphicFrameMkLst>
-            <pc:docMk/>
-            <pc:sldMk cId="0" sldId="257"/>
-            <ac:graphicFrameMk id="26" creationId="{00000000-0000-0000-0000-000000000000}"/>
-          </ac:graphicFrameMkLst>
-        </pc:graphicFrameChg>
-        <pc:picChg chg="mod replId">
-          <ac:chgData name="Shivam Singh" userId="e52e9ba4b5bcdf08" providerId="LiveId" clId="{341AFF7A-C5CD-4491-9020-97A9030EB6ED}" dt="2026-08-15T06:31:47.763" v="0" actId="26606"/>
-          <ac:picMkLst>
-            <pc:docMk/>
-            <pc:sldMk cId="0" sldId="257"/>
-            <ac:picMk id="49" creationId="{00000000-0000-0000-0000-000000000000}"/>
-          </ac:picMkLst>
-        </pc:picChg>
-      </pc:sldChg>
-      <pc:sldChg chg="addSp delSp modSp mod ord">
-        <pc:chgData name="Shivam Singh" userId="e52e9ba4b5bcdf08" providerId="LiveId" clId="{341AFF7A-C5CD-4491-9020-97A9030EB6ED}" dt="2026-08-15T06:52:05.400" v="139" actId="26606"/>
-        <pc:sldMkLst>
-          <pc:docMk/>
-          <pc:sldMk cId="0" sldId="258"/>
-        </pc:sldMkLst>
-        <pc:spChg chg="mod">
-          <ac:chgData name="Shivam Singh" userId="e52e9ba4b5bcdf08" providerId="LiveId" clId="{341AFF7A-C5CD-4491-9020-97A9030EB6ED}" dt="2026-08-15T06:52:05.400" v="139" actId="26606"/>
-          <ac:spMkLst>
-            <pc:docMk/>
-            <pc:sldMk cId="0" sldId="258"/>
-            <ac:spMk id="2" creationId="{00000000-0000-0000-0000-000000000000}"/>
-          </ac:spMkLst>
-        </pc:spChg>
-        <pc:spChg chg="mod">
-          <ac:chgData name="Shivam Singh" userId="e52e9ba4b5bcdf08" providerId="LiveId" clId="{341AFF7A-C5CD-4491-9020-97A9030EB6ED}" dt="2026-08-15T06:31:48.831" v="1" actId="26606"/>
-          <ac:spMkLst>
-            <pc:docMk/>
-            <pc:sldMk cId="0" sldId="258"/>
-            <ac:spMk id="3" creationId="{00000000-0000-0000-0000-000000000000}"/>
-          </ac:spMkLst>
-        </pc:spChg>
-        <pc:spChg chg="mod">
-          <ac:chgData name="Shivam Singh" userId="e52e9ba4b5bcdf08" providerId="LiveId" clId="{341AFF7A-C5CD-4491-9020-97A9030EB6ED}" dt="2026-08-15T06:31:48.831" v="1" actId="26606"/>
-          <ac:spMkLst>
-            <pc:docMk/>
-            <pc:sldMk cId="0" sldId="258"/>
-            <ac:spMk id="4" creationId="{00000000-0000-0000-0000-000000000000}"/>
-          </ac:spMkLst>
-        </pc:spChg>
-        <pc:spChg chg="mod">
-          <ac:chgData name="Shivam Singh" userId="e52e9ba4b5bcdf08" providerId="LiveId" clId="{341AFF7A-C5CD-4491-9020-97A9030EB6ED}" dt="2026-08-15T06:31:48.831" v="1" actId="26606"/>
-          <ac:spMkLst>
-            <pc:docMk/>
-            <pc:sldMk cId="0" sldId="258"/>
-            <ac:spMk id="8" creationId="{00000000-0000-0000-0000-000000000000}"/>
-          </ac:spMkLst>
-        </pc:spChg>
-        <pc:spChg chg="mod">
-          <ac:chgData name="Shivam Singh" userId="e52e9ba4b5bcdf08" providerId="LiveId" clId="{341AFF7A-C5CD-4491-9020-97A9030EB6ED}" dt="2026-08-15T06:31:48.831" v="1" actId="26606"/>
-          <ac:spMkLst>
-            <pc:docMk/>
-            <pc:sldMk cId="0" sldId="258"/>
-            <ac:spMk id="9" creationId="{00000000-0000-0000-0000-000000000000}"/>
-          </ac:spMkLst>
-        </pc:spChg>
-        <pc:spChg chg="mod">
-          <ac:chgData name="Shivam Singh" userId="e52e9ba4b5bcdf08" providerId="LiveId" clId="{341AFF7A-C5CD-4491-9020-97A9030EB6ED}" dt="2026-08-15T06:31:48.831" v="1" actId="26606"/>
-          <ac:spMkLst>
-            <pc:docMk/>
-            <pc:sldMk cId="0" sldId="258"/>
-            <ac:spMk id="10" creationId="{00000000-0000-0000-0000-000000000000}"/>
-          </ac:spMkLst>
-        </pc:spChg>
-        <pc:spChg chg="mod">
-          <ac:chgData name="Shivam Singh" userId="e52e9ba4b5bcdf08" providerId="LiveId" clId="{341AFF7A-C5CD-4491-9020-97A9030EB6ED}" dt="2026-08-15T06:52:05.400" v="139" actId="26606"/>
-          <ac:spMkLst>
-            <pc:docMk/>
-            <pc:sldMk cId="0" sldId="258"/>
-            <ac:spMk id="15" creationId="{00000000-0000-0000-0000-000000000000}"/>
-          </ac:spMkLst>
-        </pc:spChg>
-        <pc:spChg chg="mod">
-          <ac:chgData name="Shivam Singh" userId="e52e9ba4b5bcdf08" providerId="LiveId" clId="{341AFF7A-C5CD-4491-9020-97A9030EB6ED}" dt="2026-08-15T06:52:05.400" v="139" actId="26606"/>
-          <ac:spMkLst>
-            <pc:docMk/>
-            <pc:sldMk cId="0" sldId="258"/>
-            <ac:spMk id="19" creationId="{00000000-0000-0000-0000-000000000000}"/>
-          </ac:spMkLst>
-        </pc:spChg>
-        <pc:spChg chg="del">
-          <ac:chgData name="Shivam Singh" userId="e52e9ba4b5bcdf08" providerId="LiveId" clId="{341AFF7A-C5CD-4491-9020-97A9030EB6ED}" dt="2026-08-15T06:31:48.831" v="1" actId="26606"/>
-          <ac:spMkLst>
-            <pc:docMk/>
-            <pc:sldMk cId="0" sldId="258"/>
-            <ac:spMk id="23" creationId="{00000000-0000-0000-0000-000000000000}"/>
-          </ac:spMkLst>
-        </pc:spChg>
-        <pc:spChg chg="del">
-          <ac:chgData name="Shivam Singh" userId="e52e9ba4b5bcdf08" providerId="LiveId" clId="{341AFF7A-C5CD-4491-9020-97A9030EB6ED}" dt="2026-08-15T06:31:48.831" v="1" actId="26606"/>
-          <ac:spMkLst>
-            <pc:docMk/>
-            <pc:sldMk cId="0" sldId="258"/>
-            <ac:spMk id="25" creationId="{00000000-0000-0000-0000-000000000000}"/>
-          </ac:spMkLst>
-        </pc:spChg>
-        <pc:spChg chg="del">
-          <ac:chgData name="Shivam Singh" userId="e52e9ba4b5bcdf08" providerId="LiveId" clId="{341AFF7A-C5CD-4491-9020-97A9030EB6ED}" dt="2026-08-15T06:31:48.831" v="1" actId="26606"/>
-          <ac:spMkLst>
-            <pc:docMk/>
-            <pc:sldMk cId="0" sldId="258"/>
-            <ac:spMk id="26" creationId="{00000000-0000-0000-0000-000000000000}"/>
-          </ac:spMkLst>
-        </pc:spChg>
-        <pc:spChg chg="del mod replId">
-          <ac:chgData name="Shivam Singh" userId="e52e9ba4b5bcdf08" providerId="LiveId" clId="{341AFF7A-C5CD-4491-9020-97A9030EB6ED}" dt="2026-08-15T06:31:48.831" v="1" actId="26606"/>
-          <ac:spMkLst>
-            <pc:docMk/>
-            <pc:sldMk cId="0" sldId="258"/>
-            <ac:spMk id="27" creationId="{00000000-0000-0000-0000-000000000000}"/>
-          </ac:spMkLst>
-        </pc:spChg>
-        <pc:spChg chg="mod replId">
-          <ac:chgData name="Shivam Singh" userId="e52e9ba4b5bcdf08" providerId="LiveId" clId="{341AFF7A-C5CD-4491-9020-97A9030EB6ED}" dt="2026-08-15T06:31:47.763" v="0" actId="26606"/>
-          <ac:spMkLst>
-            <pc:docMk/>
-            <pc:sldMk cId="0" sldId="258"/>
-            <ac:spMk id="29" creationId="{00000000-0000-0000-0000-000000000000}"/>
-          </ac:spMkLst>
-        </pc:spChg>
-        <pc:picChg chg="mod replId">
-          <ac:chgData name="Shivam Singh" userId="e52e9ba4b5bcdf08" providerId="LiveId" clId="{341AFF7A-C5CD-4491-9020-97A9030EB6ED}" dt="2026-08-15T06:31:47.763" v="0" actId="26606"/>
-          <ac:picMkLst>
-            <pc:docMk/>
-            <pc:sldMk cId="0" sldId="258"/>
-            <ac:picMk id="28" creationId="{00000000-0000-0000-0000-000000000000}"/>
-          </ac:picMkLst>
-        </pc:picChg>
-      </pc:sldChg>
-      <pc:sldChg chg="addSp delSp modSp mod setBg">
-        <pc:chgData name="Shivam Singh" userId="e52e9ba4b5bcdf08" providerId="LiveId" clId="{341AFF7A-C5CD-4491-9020-97A9030EB6ED}" dt="2026-08-15T06:52:05.400" v="139" actId="26606"/>
-        <pc:sldMkLst>
-          <pc:docMk/>
-          <pc:sldMk cId="0" sldId="259"/>
-        </pc:sldMkLst>
-        <pc:spChg chg="mod">
-          <ac:chgData name="Shivam Singh" userId="e52e9ba4b5bcdf08" providerId="LiveId" clId="{341AFF7A-C5CD-4491-9020-97A9030EB6ED}" dt="2026-08-15T06:52:05.400" v="139" actId="26606"/>
-          <ac:spMkLst>
-            <pc:docMk/>
-            <pc:sldMk cId="0" sldId="259"/>
-            <ac:spMk id="2" creationId="{00000000-0000-0000-0000-000000000000}"/>
-          </ac:spMkLst>
-        </pc:spChg>
-        <pc:spChg chg="mod">
-          <ac:chgData name="Shivam Singh" userId="e52e9ba4b5bcdf08" providerId="LiveId" clId="{341AFF7A-C5CD-4491-9020-97A9030EB6ED}" dt="2026-08-15T06:31:48.831" v="1" actId="26606"/>
-          <ac:spMkLst>
-            <pc:docMk/>
-            <pc:sldMk cId="0" sldId="259"/>
-            <ac:spMk id="4" creationId="{00000000-0000-0000-0000-000000000000}"/>
-          </ac:spMkLst>
-        </pc:spChg>
-        <pc:spChg chg="mod">
-          <ac:chgData name="Shivam Singh" userId="e52e9ba4b5bcdf08" providerId="LiveId" clId="{341AFF7A-C5CD-4491-9020-97A9030EB6ED}" dt="2026-08-15T06:52:05.400" v="139" actId="26606"/>
-          <ac:spMkLst>
-            <pc:docMk/>
-            <pc:sldMk cId="0" sldId="259"/>
-            <ac:spMk id="7" creationId="{00000000-0000-0000-0000-000000000000}"/>
-          </ac:spMkLst>
-        </pc:spChg>
-        <pc:spChg chg="mod">
-          <ac:chgData name="Shivam Singh" userId="e52e9ba4b5bcdf08" providerId="LiveId" clId="{341AFF7A-C5CD-4491-9020-97A9030EB6ED}" dt="2026-08-15T06:52:05.400" v="139" actId="26606"/>
-          <ac:spMkLst>
-            <pc:docMk/>
-            <pc:sldMk cId="0" sldId="259"/>
-            <ac:spMk id="9" creationId="{00000000-0000-0000-0000-000000000000}"/>
-          </ac:spMkLst>
-        </pc:spChg>
-        <pc:spChg chg="mod">
-          <ac:chgData name="Shivam Singh" userId="e52e9ba4b5bcdf08" providerId="LiveId" clId="{341AFF7A-C5CD-4491-9020-97A9030EB6ED}" dt="2026-08-15T06:31:48.831" v="1" actId="26606"/>
-          <ac:spMkLst>
-            <pc:docMk/>
-            <pc:sldMk cId="0" sldId="259"/>
-            <ac:spMk id="13" creationId="{00000000-0000-0000-0000-000000000000}"/>
-          </ac:spMkLst>
-        </pc:spChg>
-        <pc:spChg chg="mod">
-          <ac:chgData name="Shivam Singh" userId="e52e9ba4b5bcdf08" providerId="LiveId" clId="{341AFF7A-C5CD-4491-9020-97A9030EB6ED}" dt="2026-08-15T06:52:05.400" v="139" actId="26606"/>
-          <ac:spMkLst>
-            <pc:docMk/>
-            <pc:sldMk cId="0" sldId="259"/>
-            <ac:spMk id="20" creationId="{00000000-0000-0000-0000-000000000000}"/>
-          </ac:spMkLst>
-        </pc:spChg>
-        <pc:spChg chg="mod">
-          <ac:chgData name="Shivam Singh" userId="e52e9ba4b5bcdf08" providerId="LiveId" clId="{341AFF7A-C5CD-4491-9020-97A9030EB6ED}" dt="2026-08-15T06:52:05.400" v="139" actId="26606"/>
-          <ac:spMkLst>
-            <pc:docMk/>
-            <pc:sldMk cId="0" sldId="259"/>
-            <ac:spMk id="23" creationId="{00000000-0000-0000-0000-000000000000}"/>
-          </ac:spMkLst>
-        </pc:spChg>
-        <pc:spChg chg="del">
-          <ac:chgData name="Shivam Singh" userId="e52e9ba4b5bcdf08" providerId="LiveId" clId="{341AFF7A-C5CD-4491-9020-97A9030EB6ED}" dt="2026-08-15T06:31:48.831" v="1" actId="26606"/>
-          <ac:spMkLst>
-            <pc:docMk/>
-            <pc:sldMk cId="0" sldId="259"/>
-            <ac:spMk id="25" creationId="{00000000-0000-0000-0000-000000000000}"/>
-          </ac:spMkLst>
-        </pc:spChg>
-        <pc:spChg chg="del">
-          <ac:chgData name="Shivam Singh" userId="e52e9ba4b5bcdf08" providerId="LiveId" clId="{341AFF7A-C5CD-4491-9020-97A9030EB6ED}" dt="2026-08-15T06:31:48.831" v="1" actId="26606"/>
-          <ac:spMkLst>
-            <pc:docMk/>
-            <pc:sldMk cId="0" sldId="259"/>
-            <ac:spMk id="27" creationId="{00000000-0000-0000-0000-000000000000}"/>
-          </ac:spMkLst>
-        </pc:spChg>
-        <pc:spChg chg="del">
-          <ac:chgData name="Shivam Singh" userId="e52e9ba4b5bcdf08" providerId="LiveId" clId="{341AFF7A-C5CD-4491-9020-97A9030EB6ED}" dt="2026-08-15T06:31:48.831" v="1" actId="26606"/>
-          <ac:spMkLst>
-            <pc:docMk/>
-            <pc:sldMk cId="0" sldId="259"/>
-            <ac:spMk id="32" creationId="{00000000-0000-0000-0000-000000000000}"/>
-          </ac:spMkLst>
-        </pc:spChg>
-        <pc:spChg chg="del">
-          <ac:chgData name="Shivam Singh" userId="e52e9ba4b5bcdf08" providerId="LiveId" clId="{341AFF7A-C5CD-4491-9020-97A9030EB6ED}" dt="2026-08-15T06:31:48.831" v="1" actId="26606"/>
-          <ac:spMkLst>
-            <pc:docMk/>
-            <pc:sldMk cId="0" sldId="259"/>
-            <ac:spMk id="35" creationId="{00000000-0000-0000-0000-000000000000}"/>
-          </ac:spMkLst>
-        </pc:spChg>
-        <pc:spChg chg="del">
-          <ac:chgData name="Shivam Singh" userId="e52e9ba4b5bcdf08" providerId="LiveId" clId="{341AFF7A-C5CD-4491-9020-97A9030EB6ED}" dt="2026-08-15T06:31:48.831" v="1" actId="26606"/>
-          <ac:spMkLst>
-            <pc:docMk/>
-            <pc:sldMk cId="0" sldId="259"/>
-            <ac:spMk id="40" creationId="{00000000-0000-0000-0000-000000000000}"/>
-          </ac:spMkLst>
-        </pc:spChg>
-        <pc:spChg chg="del">
-          <ac:chgData name="Shivam Singh" userId="e52e9ba4b5bcdf08" providerId="LiveId" clId="{341AFF7A-C5CD-4491-9020-97A9030EB6ED}" dt="2026-08-15T06:31:48.831" v="1" actId="26606"/>
-          <ac:spMkLst>
-            <pc:docMk/>
-            <pc:sldMk cId="0" sldId="259"/>
-            <ac:spMk id="49" creationId="{00000000-0000-0000-0000-000000000000}"/>
-          </ac:spMkLst>
-        </pc:spChg>
-        <pc:spChg chg="mod replId">
-          <ac:chgData name="Shivam Singh" userId="e52e9ba4b5bcdf08" providerId="LiveId" clId="{341AFF7A-C5CD-4491-9020-97A9030EB6ED}" dt="2026-08-15T06:31:47.763" v="0" actId="26606"/>
-          <ac:spMkLst>
-            <pc:docMk/>
-            <pc:sldMk cId="0" sldId="259"/>
-            <ac:spMk id="51" creationId="{00000000-0000-0000-0000-000000000000}"/>
-          </ac:spMkLst>
-        </pc:spChg>
-        <pc:spChg chg="mod replId">
-          <ac:chgData name="Shivam Singh" userId="e52e9ba4b5bcdf08" providerId="LiveId" clId="{341AFF7A-C5CD-4491-9020-97A9030EB6ED}" dt="2026-08-15T06:31:47.763" v="0" actId="26606"/>
-          <ac:spMkLst>
-            <pc:docMk/>
-            <pc:sldMk cId="0" sldId="259"/>
-            <ac:spMk id="53" creationId="{00000000-0000-0000-0000-000000000000}"/>
-          </ac:spMkLst>
-        </pc:spChg>
-        <pc:picChg chg="mod replId">
-          <ac:chgData name="Shivam Singh" userId="e52e9ba4b5bcdf08" providerId="LiveId" clId="{341AFF7A-C5CD-4491-9020-97A9030EB6ED}" dt="2026-08-15T06:31:47.763" v="0" actId="26606"/>
-          <ac:picMkLst>
-            <pc:docMk/>
-            <pc:sldMk cId="0" sldId="259"/>
-            <ac:picMk id="52" creationId="{00000000-0000-0000-0000-000000000000}"/>
-          </ac:picMkLst>
-        </pc:picChg>
-      </pc:sldChg>
-      <pc:sldChg chg="addSp delSp modSp mod">
-        <pc:chgData name="Shivam Singh" userId="e52e9ba4b5bcdf08" providerId="LiveId" clId="{341AFF7A-C5CD-4491-9020-97A9030EB6ED}" dt="2026-08-15T06:52:05.400" v="139" actId="26606"/>
-        <pc:sldMkLst>
-          <pc:docMk/>
-          <pc:sldMk cId="0" sldId="260"/>
-        </pc:sldMkLst>
-        <pc:spChg chg="mod">
-          <ac:chgData name="Shivam Singh" userId="e52e9ba4b5bcdf08" providerId="LiveId" clId="{341AFF7A-C5CD-4491-9020-97A9030EB6ED}" dt="2026-08-15T06:52:05.400" v="139" actId="26606"/>
-          <ac:spMkLst>
-            <pc:docMk/>
-            <pc:sldMk cId="0" sldId="260"/>
-            <ac:spMk id="2" creationId="{00000000-0000-0000-0000-000000000000}"/>
-          </ac:spMkLst>
-        </pc:spChg>
-        <pc:spChg chg="mod">
-          <ac:chgData name="Shivam Singh" userId="e52e9ba4b5bcdf08" providerId="LiveId" clId="{341AFF7A-C5CD-4491-9020-97A9030EB6ED}" dt="2026-08-15T06:31:48.831" v="1" actId="26606"/>
-          <ac:spMkLst>
-            <pc:docMk/>
-            <pc:sldMk cId="0" sldId="260"/>
-            <ac:spMk id="9" creationId="{00000000-0000-0000-0000-000000000000}"/>
-          </ac:spMkLst>
-        </pc:spChg>
-        <pc:spChg chg="mod">
-          <ac:chgData name="Shivam Singh" userId="e52e9ba4b5bcdf08" providerId="LiveId" clId="{341AFF7A-C5CD-4491-9020-97A9030EB6ED}" dt="2026-08-15T06:31:48.831" v="1" actId="26606"/>
-          <ac:spMkLst>
-            <pc:docMk/>
-            <pc:sldMk cId="0" sldId="260"/>
-            <ac:spMk id="11" creationId="{00000000-0000-0000-0000-000000000000}"/>
-          </ac:spMkLst>
-        </pc:spChg>
-        <pc:spChg chg="mod">
-          <ac:chgData name="Shivam Singh" userId="e52e9ba4b5bcdf08" providerId="LiveId" clId="{341AFF7A-C5CD-4491-9020-97A9030EB6ED}" dt="2026-08-15T06:52:05.400" v="139" actId="26606"/>
-          <ac:spMkLst>
-            <pc:docMk/>
-            <pc:sldMk cId="0" sldId="260"/>
-            <ac:spMk id="26" creationId="{00000000-0000-0000-0000-000000000000}"/>
-          </ac:spMkLst>
-        </pc:spChg>
-        <pc:spChg chg="del">
-          <ac:chgData name="Shivam Singh" userId="e52e9ba4b5bcdf08" providerId="LiveId" clId="{341AFF7A-C5CD-4491-9020-97A9030EB6ED}" dt="2026-08-15T06:31:48.831" v="1" actId="26606"/>
-          <ac:spMkLst>
-            <pc:docMk/>
-            <pc:sldMk cId="0" sldId="260"/>
-            <ac:spMk id="28" creationId="{00000000-0000-0000-0000-000000000000}"/>
-          </ac:spMkLst>
-        </pc:spChg>
-        <pc:spChg chg="del">
-          <ac:chgData name="Shivam Singh" userId="e52e9ba4b5bcdf08" providerId="LiveId" clId="{341AFF7A-C5CD-4491-9020-97A9030EB6ED}" dt="2026-08-15T06:31:48.831" v="1" actId="26606"/>
-          <ac:spMkLst>
-            <pc:docMk/>
-            <pc:sldMk cId="0" sldId="260"/>
-            <ac:spMk id="32" creationId="{00000000-0000-0000-0000-000000000000}"/>
-          </ac:spMkLst>
-        </pc:spChg>
-        <pc:spChg chg="del">
-          <ac:chgData name="Shivam Singh" userId="e52e9ba4b5bcdf08" providerId="LiveId" clId="{341AFF7A-C5CD-4491-9020-97A9030EB6ED}" dt="2026-08-15T06:31:48.831" v="1" actId="26606"/>
-          <ac:spMkLst>
-            <pc:docMk/>
-            <pc:sldMk cId="0" sldId="260"/>
-            <ac:spMk id="50" creationId="{00000000-0000-0000-0000-000000000000}"/>
-          </ac:spMkLst>
-        </pc:spChg>
-        <pc:spChg chg="del">
-          <ac:chgData name="Shivam Singh" userId="e52e9ba4b5bcdf08" providerId="LiveId" clId="{341AFF7A-C5CD-4491-9020-97A9030EB6ED}" dt="2026-08-15T06:31:48.831" v="1" actId="26606"/>
-          <ac:spMkLst>
-            <pc:docMk/>
-            <pc:sldMk cId="0" sldId="260"/>
-            <ac:spMk id="52" creationId="{00000000-0000-0000-0000-000000000000}"/>
-          </ac:spMkLst>
-        </pc:spChg>
-        <pc:spChg chg="del">
-          <ac:chgData name="Shivam Singh" userId="e52e9ba4b5bcdf08" providerId="LiveId" clId="{341AFF7A-C5CD-4491-9020-97A9030EB6ED}" dt="2026-08-15T06:31:48.831" v="1" actId="26606"/>
-          <ac:spMkLst>
-            <pc:docMk/>
-            <pc:sldMk cId="0" sldId="260"/>
-            <ac:spMk id="54" creationId="{00000000-0000-0000-0000-000000000000}"/>
-          </ac:spMkLst>
-        </pc:spChg>
-        <pc:spChg chg="del">
-          <ac:chgData name="Shivam Singh" userId="e52e9ba4b5bcdf08" providerId="LiveId" clId="{341AFF7A-C5CD-4491-9020-97A9030EB6ED}" dt="2026-08-15T06:31:48.831" v="1" actId="26606"/>
-          <ac:spMkLst>
-            <pc:docMk/>
-            <pc:sldMk cId="0" sldId="260"/>
-            <ac:spMk id="55" creationId="{00000000-0000-0000-0000-000000000000}"/>
-          </ac:spMkLst>
-        </pc:spChg>
-        <pc:spChg chg="del">
-          <ac:chgData name="Shivam Singh" userId="e52e9ba4b5bcdf08" providerId="LiveId" clId="{341AFF7A-C5CD-4491-9020-97A9030EB6ED}" dt="2026-08-15T06:31:48.831" v="1" actId="26606"/>
-          <ac:spMkLst>
-            <pc:docMk/>
-            <pc:sldMk cId="0" sldId="260"/>
-            <ac:spMk id="57" creationId="{00000000-0000-0000-0000-000000000000}"/>
-          </ac:spMkLst>
-        </pc:spChg>
-        <pc:spChg chg="mod replId">
-          <ac:chgData name="Shivam Singh" userId="e52e9ba4b5bcdf08" providerId="LiveId" clId="{341AFF7A-C5CD-4491-9020-97A9030EB6ED}" dt="2026-08-15T06:31:47.763" v="0" actId="26606"/>
-          <ac:spMkLst>
-            <pc:docMk/>
-            <pc:sldMk cId="0" sldId="260"/>
-            <ac:spMk id="63" creationId="{00000000-0000-0000-0000-000000000000}"/>
-          </ac:spMkLst>
-        </pc:spChg>
-        <pc:spChg chg="mod replId">
-          <ac:chgData name="Shivam Singh" userId="e52e9ba4b5bcdf08" providerId="LiveId" clId="{341AFF7A-C5CD-4491-9020-97A9030EB6ED}" dt="2026-08-15T06:31:47.763" v="0" actId="26606"/>
-          <ac:spMkLst>
-            <pc:docMk/>
-            <pc:sldMk cId="0" sldId="260"/>
-            <ac:spMk id="65" creationId="{00000000-0000-0000-0000-000000000000}"/>
-          </ac:spMkLst>
-        </pc:spChg>
-        <pc:picChg chg="mod replId">
-          <ac:chgData name="Shivam Singh" userId="e52e9ba4b5bcdf08" providerId="LiveId" clId="{341AFF7A-C5CD-4491-9020-97A9030EB6ED}" dt="2026-08-15T06:31:47.763" v="0" actId="26606"/>
-          <ac:picMkLst>
-            <pc:docMk/>
-            <pc:sldMk cId="0" sldId="260"/>
-            <ac:picMk id="64" creationId="{00000000-0000-0000-0000-000000000000}"/>
-          </ac:picMkLst>
-        </pc:picChg>
-      </pc:sldChg>
-      <pc:sldChg chg="addSp delSp modSp del mod">
-        <pc:chgData name="Shivam Singh" userId="e52e9ba4b5bcdf08" providerId="LiveId" clId="{341AFF7A-C5CD-4491-9020-97A9030EB6ED}" dt="2026-08-15T06:32:42.978" v="2" actId="47"/>
-        <pc:sldMkLst>
-          <pc:docMk/>
-          <pc:sldMk cId="0" sldId="261"/>
-        </pc:sldMkLst>
-        <pc:spChg chg="mod">
-          <ac:chgData name="Shivam Singh" userId="e52e9ba4b5bcdf08" providerId="LiveId" clId="{341AFF7A-C5CD-4491-9020-97A9030EB6ED}" dt="2026-08-15T06:31:48.831" v="1" actId="26606"/>
-          <ac:spMkLst>
-            <pc:docMk/>
-            <pc:sldMk cId="0" sldId="261"/>
-            <ac:spMk id="2" creationId="{00000000-0000-0000-0000-000000000000}"/>
-          </ac:spMkLst>
-        </pc:spChg>
-        <pc:spChg chg="add">
-          <ac:chgData name="Shivam Singh" userId="e52e9ba4b5bcdf08" providerId="LiveId" clId="{341AFF7A-C5CD-4491-9020-97A9030EB6ED}" dt="2026-08-15T06:31:48.831" v="1" actId="26606"/>
-          <ac:spMkLst>
-            <pc:docMk/>
-            <pc:sldMk cId="0" sldId="261"/>
-            <ac:spMk id="8" creationId="{00000000-0000-0000-0000-000000000000}"/>
-          </ac:spMkLst>
-        </pc:spChg>
-        <pc:spChg chg="add">
-          <ac:chgData name="Shivam Singh" userId="e52e9ba4b5bcdf08" providerId="LiveId" clId="{341AFF7A-C5CD-4491-9020-97A9030EB6ED}" dt="2026-08-15T06:31:48.831" v="1" actId="26606"/>
-          <ac:spMkLst>
-            <pc:docMk/>
-            <pc:sldMk cId="0" sldId="261"/>
-            <ac:spMk id="9" creationId="{00000000-0000-0000-0000-000000000000}"/>
-          </ac:spMkLst>
-        </pc:spChg>
-        <pc:spChg chg="add">
-          <ac:chgData name="Shivam Singh" userId="e52e9ba4b5bcdf08" providerId="LiveId" clId="{341AFF7A-C5CD-4491-9020-97A9030EB6ED}" dt="2026-08-15T06:31:48.831" v="1" actId="26606"/>
-          <ac:spMkLst>
-            <pc:docMk/>
-            <pc:sldMk cId="0" sldId="261"/>
-            <ac:spMk id="10" creationId="{00000000-0000-0000-0000-000000000000}"/>
-          </ac:spMkLst>
-        </pc:spChg>
-        <pc:spChg chg="add">
-          <ac:chgData name="Shivam Singh" userId="e52e9ba4b5bcdf08" providerId="LiveId" clId="{341AFF7A-C5CD-4491-9020-97A9030EB6ED}" dt="2026-08-15T06:31:48.831" v="1" actId="26606"/>
-          <ac:spMkLst>
-            <pc:docMk/>
-            <pc:sldMk cId="0" sldId="261"/>
-            <ac:spMk id="15" creationId="{00000000-0000-0000-0000-000000000000}"/>
-          </ac:spMkLst>
-        </pc:spChg>
-        <pc:spChg chg="add">
-          <ac:chgData name="Shivam Singh" userId="e52e9ba4b5bcdf08" providerId="LiveId" clId="{341AFF7A-C5CD-4491-9020-97A9030EB6ED}" dt="2026-08-15T06:31:48.831" v="1" actId="26606"/>
-          <ac:spMkLst>
-            <pc:docMk/>
-            <pc:sldMk cId="0" sldId="261"/>
-            <ac:spMk id="17" creationId="{00000000-0000-0000-0000-000000000000}"/>
-          </ac:spMkLst>
-        </pc:spChg>
-        <pc:spChg chg="add">
-          <ac:chgData name="Shivam Singh" userId="e52e9ba4b5bcdf08" providerId="LiveId" clId="{341AFF7A-C5CD-4491-9020-97A9030EB6ED}" dt="2026-08-15T06:31:48.831" v="1" actId="26606"/>
-          <ac:spMkLst>
-            <pc:docMk/>
-            <pc:sldMk cId="0" sldId="261"/>
-            <ac:spMk id="19" creationId="{00000000-0000-0000-0000-000000000000}"/>
-          </ac:spMkLst>
-        </pc:spChg>
-        <pc:spChg chg="add">
-          <ac:chgData name="Shivam Singh" userId="e52e9ba4b5bcdf08" providerId="LiveId" clId="{341AFF7A-C5CD-4491-9020-97A9030EB6ED}" dt="2026-08-15T06:31:48.831" v="1" actId="26606"/>
-          <ac:spMkLst>
-            <pc:docMk/>
-            <pc:sldMk cId="0" sldId="261"/>
-            <ac:spMk id="25" creationId="{00000000-0000-0000-0000-000000000000}"/>
-          </ac:spMkLst>
-        </pc:spChg>
-        <pc:spChg chg="add">
-          <ac:chgData name="Shivam Singh" userId="e52e9ba4b5bcdf08" providerId="LiveId" clId="{341AFF7A-C5CD-4491-9020-97A9030EB6ED}" dt="2026-08-15T06:31:48.831" v="1" actId="26606"/>
-          <ac:spMkLst>
-            <pc:docMk/>
-            <pc:sldMk cId="0" sldId="261"/>
-            <ac:spMk id="26" creationId="{00000000-0000-0000-0000-000000000000}"/>
-          </ac:spMkLst>
-        </pc:spChg>
-        <pc:spChg chg="del mod replId">
-          <ac:chgData name="Shivam Singh" userId="e52e9ba4b5bcdf08" providerId="LiveId" clId="{341AFF7A-C5CD-4491-9020-97A9030EB6ED}" dt="2026-08-15T06:31:48.831" v="1" actId="26606"/>
-          <ac:spMkLst>
-            <pc:docMk/>
-            <pc:sldMk cId="0" sldId="261"/>
-            <ac:spMk id="37" creationId="{00000000-0000-0000-0000-000000000000}"/>
-          </ac:spMkLst>
-        </pc:spChg>
-        <pc:graphicFrameChg chg="mod replId">
-          <ac:chgData name="Shivam Singh" userId="e52e9ba4b5bcdf08" providerId="LiveId" clId="{341AFF7A-C5CD-4491-9020-97A9030EB6ED}" dt="2026-08-15T06:31:47.763" v="0" actId="26606"/>
-          <ac:graphicFrameMkLst>
-            <pc:docMk/>
-            <pc:sldMk cId="0" sldId="261"/>
-            <ac:graphicFrameMk id="39" creationId="{00000000-0000-0000-0000-000000000000}"/>
-          </ac:graphicFrameMkLst>
-        </pc:graphicFrameChg>
-        <pc:picChg chg="mod replId">
-          <ac:chgData name="Shivam Singh" userId="e52e9ba4b5bcdf08" providerId="LiveId" clId="{341AFF7A-C5CD-4491-9020-97A9030EB6ED}" dt="2026-08-15T06:31:47.763" v="0" actId="26606"/>
-          <ac:picMkLst>
-            <pc:docMk/>
-            <pc:sldMk cId="0" sldId="261"/>
-            <ac:picMk id="38" creationId="{00000000-0000-0000-0000-000000000000}"/>
-          </ac:picMkLst>
-        </pc:picChg>
-      </pc:sldChg>
-      <pc:sldChg chg="addSp delSp modSp mod ord">
-        <pc:chgData name="Shivam Singh" userId="e52e9ba4b5bcdf08" providerId="LiveId" clId="{341AFF7A-C5CD-4491-9020-97A9030EB6ED}" dt="2026-08-15T06:52:17.081" v="152" actId="20577"/>
-        <pc:sldMkLst>
-          <pc:docMk/>
-          <pc:sldMk cId="2670328286" sldId="266"/>
-        </pc:sldMkLst>
-        <pc:spChg chg="add mod">
-          <ac:chgData name="Shivam Singh" userId="e52e9ba4b5bcdf08" providerId="LiveId" clId="{341AFF7A-C5CD-4491-9020-97A9030EB6ED}" dt="2026-08-15T06:52:17.081" v="152" actId="20577"/>
-          <ac:spMkLst>
-            <pc:docMk/>
-            <pc:sldMk cId="2670328286" sldId="266"/>
-            <ac:spMk id="2" creationId="{00000000-0000-0000-0000-000000000000}"/>
-          </ac:spMkLst>
-        </pc:spChg>
-        <pc:spChg chg="add">
-          <ac:chgData name="Shivam Singh" userId="e52e9ba4b5bcdf08" providerId="LiveId" clId="{341AFF7A-C5CD-4491-9020-97A9030EB6ED}" dt="2026-08-15T06:31:48.831" v="1" actId="26606"/>
-          <ac:spMkLst>
-            <pc:docMk/>
-            <pc:sldMk cId="2670328286" sldId="266"/>
-            <ac:spMk id="4" creationId="{00000000-0000-0000-0000-000000000000}"/>
-          </ac:spMkLst>
-        </pc:spChg>
-        <pc:spChg chg="add">
-          <ac:chgData name="Shivam Singh" userId="e52e9ba4b5bcdf08" providerId="LiveId" clId="{341AFF7A-C5CD-4491-9020-97A9030EB6ED}" dt="2026-08-15T06:31:48.831" v="1" actId="26606"/>
-          <ac:spMkLst>
-            <pc:docMk/>
-            <pc:sldMk cId="2670328286" sldId="266"/>
-            <ac:spMk id="10" creationId="{00000000-0000-0000-0000-000000000000}"/>
-          </ac:spMkLst>
-        </pc:spChg>
-        <pc:spChg chg="add">
-          <ac:chgData name="Shivam Singh" userId="e52e9ba4b5bcdf08" providerId="LiveId" clId="{341AFF7A-C5CD-4491-9020-97A9030EB6ED}" dt="2026-08-15T06:31:48.831" v="1" actId="26606"/>
-          <ac:spMkLst>
-            <pc:docMk/>
-            <pc:sldMk cId="2670328286" sldId="266"/>
-            <ac:spMk id="11" creationId="{00000000-0000-0000-0000-000000000000}"/>
-          </ac:spMkLst>
-        </pc:spChg>
-        <pc:spChg chg="add">
-          <ac:chgData name="Shivam Singh" userId="e52e9ba4b5bcdf08" providerId="LiveId" clId="{341AFF7A-C5CD-4491-9020-97A9030EB6ED}" dt="2026-08-15T06:31:48.831" v="1" actId="26606"/>
-          <ac:spMkLst>
-            <pc:docMk/>
-            <pc:sldMk cId="2670328286" sldId="266"/>
-            <ac:spMk id="14" creationId="{00000000-0000-0000-0000-000000000000}"/>
-          </ac:spMkLst>
-        </pc:spChg>
-        <pc:spChg chg="add">
-          <ac:chgData name="Shivam Singh" userId="e52e9ba4b5bcdf08" providerId="LiveId" clId="{341AFF7A-C5CD-4491-9020-97A9030EB6ED}" dt="2026-08-15T06:31:48.831" v="1" actId="26606"/>
-          <ac:spMkLst>
-            <pc:docMk/>
-            <pc:sldMk cId="2670328286" sldId="266"/>
-            <ac:spMk id="22" creationId="{00000000-0000-0000-0000-000000000000}"/>
-          </ac:spMkLst>
-        </pc:spChg>
-        <pc:spChg chg="mod">
-          <ac:chgData name="Shivam Singh" userId="e52e9ba4b5bcdf08" providerId="LiveId" clId="{341AFF7A-C5CD-4491-9020-97A9030EB6ED}" dt="2026-08-15T06:52:05.400" v="139" actId="26606"/>
-          <ac:spMkLst>
-            <pc:docMk/>
-            <pc:sldMk cId="2670328286" sldId="266"/>
-            <ac:spMk id="27" creationId="{00000000-0000-0000-0000-000000000000}"/>
-          </ac:spMkLst>
-        </pc:spChg>
-        <pc:spChg chg="del">
-          <ac:chgData name="Shivam Singh" userId="e52e9ba4b5bcdf08" providerId="LiveId" clId="{341AFF7A-C5CD-4491-9020-97A9030EB6ED}" dt="2026-08-15T06:31:48.831" v="1" actId="26606"/>
-          <ac:spMkLst>
-            <pc:docMk/>
-            <pc:sldMk cId="2670328286" sldId="266"/>
-            <ac:spMk id="29" creationId="{E84A01CD-2BE1-FDDB-260A-969013F59496}"/>
-          </ac:spMkLst>
-        </pc:spChg>
-        <pc:spChg chg="del">
-          <ac:chgData name="Shivam Singh" userId="e52e9ba4b5bcdf08" providerId="LiveId" clId="{341AFF7A-C5CD-4491-9020-97A9030EB6ED}" dt="2026-08-15T06:31:48.831" v="1" actId="26606"/>
-          <ac:spMkLst>
-            <pc:docMk/>
-            <pc:sldMk cId="2670328286" sldId="266"/>
-            <ac:spMk id="33" creationId="{C0818491-358C-500C-2EA6-7B6E151529C9}"/>
-          </ac:spMkLst>
-        </pc:spChg>
-        <pc:spChg chg="mod replId">
-          <ac:chgData name="Shivam Singh" userId="e52e9ba4b5bcdf08" providerId="LiveId" clId="{341AFF7A-C5CD-4491-9020-97A9030EB6ED}" dt="2026-08-15T06:31:47.763" v="0" actId="26606"/>
-          <ac:spMkLst>
-            <pc:docMk/>
-            <pc:sldMk cId="2670328286" sldId="266"/>
-            <ac:spMk id="38" creationId="{2050F279-71D7-44AB-CD4C-C62E3EBE4390}"/>
-          </ac:spMkLst>
-        </pc:spChg>
-        <pc:spChg chg="mod replId">
-          <ac:chgData name="Shivam Singh" userId="e52e9ba4b5bcdf08" providerId="LiveId" clId="{341AFF7A-C5CD-4491-9020-97A9030EB6ED}" dt="2026-08-15T06:31:47.763" v="0" actId="26606"/>
-          <ac:spMkLst>
-            <pc:docMk/>
-            <pc:sldMk cId="2670328286" sldId="266"/>
-            <ac:spMk id="40" creationId="{112B5E73-4F3D-5E96-BE8B-D878ECCD91D7}"/>
-          </ac:spMkLst>
-        </pc:spChg>
-        <pc:spChg chg="mod replId">
-          <ac:chgData name="Shivam Singh" userId="e52e9ba4b5bcdf08" providerId="LiveId" clId="{341AFF7A-C5CD-4491-9020-97A9030EB6ED}" dt="2026-08-15T06:31:47.763" v="0" actId="26606"/>
-          <ac:spMkLst>
-            <pc:docMk/>
-            <pc:sldMk cId="2670328286" sldId="266"/>
-            <ac:spMk id="41" creationId="{2EC0B8D4-C508-2485-52C8-0FF97864C8A4}"/>
-          </ac:spMkLst>
-        </pc:spChg>
-        <pc:spChg chg="mod replId">
-          <ac:chgData name="Shivam Singh" userId="e52e9ba4b5bcdf08" providerId="LiveId" clId="{341AFF7A-C5CD-4491-9020-97A9030EB6ED}" dt="2026-08-15T06:31:47.763" v="0" actId="26606"/>
-          <ac:spMkLst>
-            <pc:docMk/>
-            <pc:sldMk cId="2670328286" sldId="266"/>
-            <ac:spMk id="46" creationId="{0FAAF95F-F1AF-8A58-129B-473161F00556}"/>
-          </ac:spMkLst>
-        </pc:spChg>
-        <pc:spChg chg="mod replId">
-          <ac:chgData name="Shivam Singh" userId="e52e9ba4b5bcdf08" providerId="LiveId" clId="{341AFF7A-C5CD-4491-9020-97A9030EB6ED}" dt="2026-08-15T06:31:47.763" v="0" actId="26606"/>
-          <ac:spMkLst>
-            <pc:docMk/>
-            <pc:sldMk cId="2670328286" sldId="266"/>
-            <ac:spMk id="49" creationId="{7054A39B-CDBE-26A2-6903-DF0819F0CAC9}"/>
-          </ac:spMkLst>
-        </pc:spChg>
-        <pc:spChg chg="mod replId">
-          <ac:chgData name="Shivam Singh" userId="e52e9ba4b5bcdf08" providerId="LiveId" clId="{341AFF7A-C5CD-4491-9020-97A9030EB6ED}" dt="2026-08-15T06:31:47.763" v="0" actId="26606"/>
-          <ac:spMkLst>
-            <pc:docMk/>
-            <pc:sldMk cId="2670328286" sldId="266"/>
-            <ac:spMk id="51" creationId="{067B92AC-8FA5-E5B0-5100-616084941122}"/>
-          </ac:spMkLst>
-        </pc:spChg>
-        <pc:spChg chg="del">
-          <ac:chgData name="Shivam Singh" userId="e52e9ba4b5bcdf08" providerId="LiveId" clId="{341AFF7A-C5CD-4491-9020-97A9030EB6ED}" dt="2026-08-15T06:31:48.831" v="1" actId="26606"/>
-          <ac:spMkLst>
-            <pc:docMk/>
-            <pc:sldMk cId="2670328286" sldId="266"/>
-            <ac:spMk id="54" creationId="{1A3B6D4E-7B83-FC32-C0FE-A17212802FA5}"/>
-          </ac:spMkLst>
-        </pc:spChg>
-        <pc:spChg chg="mod replId">
-          <ac:chgData name="Shivam Singh" userId="e52e9ba4b5bcdf08" providerId="LiveId" clId="{341AFF7A-C5CD-4491-9020-97A9030EB6ED}" dt="2026-08-15T06:31:47.763" v="0" actId="26606"/>
-          <ac:spMkLst>
-            <pc:docMk/>
-            <pc:sldMk cId="2670328286" sldId="266"/>
-            <ac:spMk id="56" creationId="{19BED886-2CD5-CC66-B4F3-A05FBD0B3B6C}"/>
-          </ac:spMkLst>
-        </pc:spChg>
-        <pc:spChg chg="mod replId">
-          <ac:chgData name="Shivam Singh" userId="e52e9ba4b5bcdf08" providerId="LiveId" clId="{341AFF7A-C5CD-4491-9020-97A9030EB6ED}" dt="2026-08-15T06:31:47.763" v="0" actId="26606"/>
-          <ac:spMkLst>
-            <pc:docMk/>
-            <pc:sldMk cId="2670328286" sldId="266"/>
-            <ac:spMk id="59" creationId="{BB85AC27-BC8C-C32A-0378-D55BCCFF89DE}"/>
-          </ac:spMkLst>
-        </pc:spChg>
-        <pc:spChg chg="mod replId">
-          <ac:chgData name="Shivam Singh" userId="e52e9ba4b5bcdf08" providerId="LiveId" clId="{341AFF7A-C5CD-4491-9020-97A9030EB6ED}" dt="2026-08-15T06:31:47.763" v="0" actId="26606"/>
-          <ac:spMkLst>
-            <pc:docMk/>
-            <pc:sldMk cId="2670328286" sldId="266"/>
-            <ac:spMk id="60" creationId="{8087C42B-ABA5-80EE-CAD8-8D4AC0E43F2A}"/>
-          </ac:spMkLst>
-        </pc:spChg>
-        <pc:spChg chg="del">
-          <ac:chgData name="Shivam Singh" userId="e52e9ba4b5bcdf08" providerId="LiveId" clId="{341AFF7A-C5CD-4491-9020-97A9030EB6ED}" dt="2026-08-15T06:31:48.831" v="1" actId="26606"/>
-          <ac:spMkLst>
-            <pc:docMk/>
-            <pc:sldMk cId="2670328286" sldId="266"/>
-            <ac:spMk id="62" creationId="{9E448902-D0E8-1FB4-9127-21FCEA5FA74D}"/>
-          </ac:spMkLst>
-        </pc:spChg>
-        <pc:spChg chg="mod replId">
-          <ac:chgData name="Shivam Singh" userId="e52e9ba4b5bcdf08" providerId="LiveId" clId="{341AFF7A-C5CD-4491-9020-97A9030EB6ED}" dt="2026-08-15T06:31:47.763" v="0" actId="26606"/>
-          <ac:spMkLst>
-            <pc:docMk/>
-            <pc:sldMk cId="2670328286" sldId="266"/>
-            <ac:spMk id="63" creationId="{806162A1-EA57-6204-DBD1-1852DC048672}"/>
-          </ac:spMkLst>
-        </pc:spChg>
-      </pc:sldChg>
-      <pc:sldChg chg="addSp delSp modSp mod">
-        <pc:chgData name="Shivam Singh" userId="e52e9ba4b5bcdf08" providerId="LiveId" clId="{341AFF7A-C5CD-4491-9020-97A9030EB6ED}" dt="2026-08-15T06:52:05.400" v="139" actId="26606"/>
-        <pc:sldMkLst>
-          <pc:docMk/>
-          <pc:sldMk cId="0" sldId="267"/>
-        </pc:sldMkLst>
-        <pc:spChg chg="mod">
-          <ac:chgData name="Shivam Singh" userId="e52e9ba4b5bcdf08" providerId="LiveId" clId="{341AFF7A-C5CD-4491-9020-97A9030EB6ED}" dt="2026-08-15T06:31:48.831" v="1" actId="26606"/>
-          <ac:spMkLst>
-            <pc:docMk/>
-            <pc:sldMk cId="0" sldId="267"/>
-            <ac:spMk id="6" creationId="{00000000-0000-0000-0000-000000000000}"/>
-          </ac:spMkLst>
-        </pc:spChg>
-        <pc:spChg chg="mod">
-          <ac:chgData name="Shivam Singh" userId="e52e9ba4b5bcdf08" providerId="LiveId" clId="{341AFF7A-C5CD-4491-9020-97A9030EB6ED}" dt="2026-08-15T06:52:05.400" v="139" actId="26606"/>
-          <ac:spMkLst>
-            <pc:docMk/>
-            <pc:sldMk cId="0" sldId="267"/>
-            <ac:spMk id="12" creationId="{00000000-0000-0000-0000-000000000000}"/>
-          </ac:spMkLst>
-        </pc:spChg>
-        <pc:spChg chg="mod">
-          <ac:chgData name="Shivam Singh" userId="e52e9ba4b5bcdf08" providerId="LiveId" clId="{341AFF7A-C5CD-4491-9020-97A9030EB6ED}" dt="2026-08-15T06:52:05.400" v="139" actId="26606"/>
-          <ac:spMkLst>
-            <pc:docMk/>
-            <pc:sldMk cId="0" sldId="267"/>
-            <ac:spMk id="16" creationId="{00000000-0000-0000-0000-000000000000}"/>
-          </ac:spMkLst>
-        </pc:spChg>
-        <pc:spChg chg="del">
-          <ac:chgData name="Shivam Singh" userId="e52e9ba4b5bcdf08" providerId="LiveId" clId="{341AFF7A-C5CD-4491-9020-97A9030EB6ED}" dt="2026-08-15T06:31:48.831" v="1" actId="26606"/>
-          <ac:spMkLst>
-            <pc:docMk/>
-            <pc:sldMk cId="0" sldId="267"/>
-            <ac:spMk id="17" creationId="{00000000-0000-0000-0000-000000000000}"/>
-          </ac:spMkLst>
-        </pc:spChg>
-        <pc:spChg chg="del">
-          <ac:chgData name="Shivam Singh" userId="e52e9ba4b5bcdf08" providerId="LiveId" clId="{341AFF7A-C5CD-4491-9020-97A9030EB6ED}" dt="2026-08-15T06:31:48.831" v="1" actId="26606"/>
-          <ac:spMkLst>
-            <pc:docMk/>
-            <pc:sldMk cId="0" sldId="267"/>
-            <ac:spMk id="18" creationId="{00000000-0000-0000-0000-000000000000}"/>
-          </ac:spMkLst>
-        </pc:spChg>
-        <pc:spChg chg="del">
-          <ac:chgData name="Shivam Singh" userId="e52e9ba4b5bcdf08" providerId="LiveId" clId="{341AFF7A-C5CD-4491-9020-97A9030EB6ED}" dt="2026-08-15T06:31:48.831" v="1" actId="26606"/>
-          <ac:spMkLst>
-            <pc:docMk/>
-            <pc:sldMk cId="0" sldId="267"/>
-            <ac:spMk id="19" creationId="{00000000-0000-0000-0000-000000000000}"/>
-          </ac:spMkLst>
-        </pc:spChg>
-        <pc:spChg chg="del">
-          <ac:chgData name="Shivam Singh" userId="e52e9ba4b5bcdf08" providerId="LiveId" clId="{341AFF7A-C5CD-4491-9020-97A9030EB6ED}" dt="2026-08-15T06:31:48.831" v="1" actId="26606"/>
-          <ac:spMkLst>
-            <pc:docMk/>
-            <pc:sldMk cId="0" sldId="267"/>
-            <ac:spMk id="23" creationId="{00000000-0000-0000-0000-000000000000}"/>
-          </ac:spMkLst>
-        </pc:spChg>
-        <pc:spChg chg="del">
-          <ac:chgData name="Shivam Singh" userId="e52e9ba4b5bcdf08" providerId="LiveId" clId="{341AFF7A-C5CD-4491-9020-97A9030EB6ED}" dt="2026-08-15T06:31:48.831" v="1" actId="26606"/>
-          <ac:spMkLst>
-            <pc:docMk/>
-            <pc:sldMk cId="0" sldId="267"/>
-            <ac:spMk id="32" creationId="{00000000-0000-0000-0000-000000000000}"/>
-          </ac:spMkLst>
-        </pc:spChg>
-        <pc:spChg chg="del">
-          <ac:chgData name="Shivam Singh" userId="e52e9ba4b5bcdf08" providerId="LiveId" clId="{341AFF7A-C5CD-4491-9020-97A9030EB6ED}" dt="2026-08-15T06:31:48.831" v="1" actId="26606"/>
-          <ac:spMkLst>
-            <pc:docMk/>
-            <pc:sldMk cId="0" sldId="267"/>
-            <ac:spMk id="40" creationId="{00000000-0000-0000-0000-000000000000}"/>
-          </ac:spMkLst>
-        </pc:spChg>
-        <pc:spChg chg="del">
-          <ac:chgData name="Shivam Singh" userId="e52e9ba4b5bcdf08" providerId="LiveId" clId="{341AFF7A-C5CD-4491-9020-97A9030EB6ED}" dt="2026-08-15T06:31:48.831" v="1" actId="26606"/>
-          <ac:spMkLst>
-            <pc:docMk/>
-            <pc:sldMk cId="0" sldId="267"/>
-            <ac:spMk id="41" creationId="{00000000-0000-0000-0000-000000000000}"/>
-          </ac:spMkLst>
-        </pc:spChg>
-        <pc:spChg chg="del">
-          <ac:chgData name="Shivam Singh" userId="e52e9ba4b5bcdf08" providerId="LiveId" clId="{341AFF7A-C5CD-4491-9020-97A9030EB6ED}" dt="2026-08-15T06:31:48.831" v="1" actId="26606"/>
-          <ac:spMkLst>
-            <pc:docMk/>
-            <pc:sldMk cId="0" sldId="267"/>
-            <ac:spMk id="43" creationId="{00000000-0000-0000-0000-000000000000}"/>
-          </ac:spMkLst>
-        </pc:spChg>
-        <pc:spChg chg="del">
-          <ac:chgData name="Shivam Singh" userId="e52e9ba4b5bcdf08" providerId="LiveId" clId="{341AFF7A-C5CD-4491-9020-97A9030EB6ED}" dt="2026-08-15T06:31:48.831" v="1" actId="26606"/>
-          <ac:spMkLst>
-            <pc:docMk/>
-            <pc:sldMk cId="0" sldId="267"/>
-            <ac:spMk id="44" creationId="{00000000-0000-0000-0000-000000000000}"/>
-          </ac:spMkLst>
-        </pc:spChg>
-        <pc:spChg chg="mod replId">
-          <ac:chgData name="Shivam Singh" userId="e52e9ba4b5bcdf08" providerId="LiveId" clId="{341AFF7A-C5CD-4491-9020-97A9030EB6ED}" dt="2026-08-15T06:31:47.763" v="0" actId="26606"/>
-          <ac:spMkLst>
-            <pc:docMk/>
-            <pc:sldMk cId="0" sldId="267"/>
-            <ac:spMk id="57" creationId="{00000000-0000-0000-0000-000000000000}"/>
-          </ac:spMkLst>
-        </pc:spChg>
-        <pc:spChg chg="mod replId">
-          <ac:chgData name="Shivam Singh" userId="e52e9ba4b5bcdf08" providerId="LiveId" clId="{341AFF7A-C5CD-4491-9020-97A9030EB6ED}" dt="2026-08-15T06:31:47.763" v="0" actId="26606"/>
-          <ac:spMkLst>
-            <pc:docMk/>
-            <pc:sldMk cId="0" sldId="267"/>
-            <ac:spMk id="58" creationId="{00000000-0000-0000-0000-000000000000}"/>
-          </ac:spMkLst>
-        </pc:spChg>
-        <pc:spChg chg="mod replId">
-          <ac:chgData name="Shivam Singh" userId="e52e9ba4b5bcdf08" providerId="LiveId" clId="{341AFF7A-C5CD-4491-9020-97A9030EB6ED}" dt="2026-08-15T06:31:47.763" v="0" actId="26606"/>
-          <ac:spMkLst>
-            <pc:docMk/>
-            <pc:sldMk cId="0" sldId="267"/>
-            <ac:spMk id="59" creationId="{00000000-0000-0000-0000-000000000000}"/>
-          </ac:spMkLst>
-        </pc:spChg>
-        <pc:spChg chg="mod replId">
-          <ac:chgData name="Shivam Singh" userId="e52e9ba4b5bcdf08" providerId="LiveId" clId="{341AFF7A-C5CD-4491-9020-97A9030EB6ED}" dt="2026-08-15T06:31:47.763" v="0" actId="26606"/>
-          <ac:spMkLst>
-            <pc:docMk/>
-            <pc:sldMk cId="0" sldId="267"/>
-            <ac:spMk id="60" creationId="{00000000-0000-0000-0000-000000000000}"/>
-          </ac:spMkLst>
-        </pc:spChg>
-      </pc:sldChg>
-      <pc:sldChg chg="addSp delSp modSp mod setBg">
-        <pc:chgData name="Shivam Singh" userId="e52e9ba4b5bcdf08" providerId="LiveId" clId="{341AFF7A-C5CD-4491-9020-97A9030EB6ED}" dt="2026-08-15T06:31:48.831" v="1" actId="26606"/>
-        <pc:sldMkLst>
-          <pc:docMk/>
-          <pc:sldMk cId="0" sldId="269"/>
-        </pc:sldMkLst>
-        <pc:spChg chg="mod">
-          <ac:chgData name="Shivam Singh" userId="e52e9ba4b5bcdf08" providerId="LiveId" clId="{341AFF7A-C5CD-4491-9020-97A9030EB6ED}" dt="2026-08-15T06:31:48.831" v="1" actId="26606"/>
-          <ac:spMkLst>
-            <pc:docMk/>
-            <pc:sldMk cId="0" sldId="269"/>
-            <ac:spMk id="3" creationId="{00000000-0000-0000-0000-000000000000}"/>
-          </ac:spMkLst>
-        </pc:spChg>
-        <pc:spChg chg="add">
-          <ac:chgData name="Shivam Singh" userId="e52e9ba4b5bcdf08" providerId="LiveId" clId="{341AFF7A-C5CD-4491-9020-97A9030EB6ED}" dt="2026-08-15T06:31:48.831" v="1" actId="26606"/>
-          <ac:spMkLst>
-            <pc:docMk/>
-            <pc:sldMk cId="0" sldId="269"/>
-            <ac:spMk id="6" creationId="{00000000-0000-0000-0000-000000000000}"/>
-          </ac:spMkLst>
-        </pc:spChg>
-        <pc:spChg chg="add">
-          <ac:chgData name="Shivam Singh" userId="e52e9ba4b5bcdf08" providerId="LiveId" clId="{341AFF7A-C5CD-4491-9020-97A9030EB6ED}" dt="2026-08-15T06:31:48.831" v="1" actId="26606"/>
-          <ac:spMkLst>
-            <pc:docMk/>
-            <pc:sldMk cId="0" sldId="269"/>
-            <ac:spMk id="8" creationId="{00000000-0000-0000-0000-000000000000}"/>
-          </ac:spMkLst>
-        </pc:spChg>
-        <pc:spChg chg="add">
-          <ac:chgData name="Shivam Singh" userId="e52e9ba4b5bcdf08" providerId="LiveId" clId="{341AFF7A-C5CD-4491-9020-97A9030EB6ED}" dt="2026-08-15T06:31:48.831" v="1" actId="26606"/>
-          <ac:spMkLst>
-            <pc:docMk/>
-            <pc:sldMk cId="0" sldId="269"/>
-            <ac:spMk id="9" creationId="{00000000-0000-0000-0000-000000000000}"/>
-          </ac:spMkLst>
-        </pc:spChg>
-        <pc:spChg chg="mod">
-          <ac:chgData name="Shivam Singh" userId="e52e9ba4b5bcdf08" providerId="LiveId" clId="{341AFF7A-C5CD-4491-9020-97A9030EB6ED}" dt="2026-08-15T06:31:48.831" v="1" actId="26606"/>
-          <ac:spMkLst>
-            <pc:docMk/>
-            <pc:sldMk cId="0" sldId="269"/>
-            <ac:spMk id="20" creationId="{00000000-0000-0000-0000-000000000000}"/>
-          </ac:spMkLst>
-        </pc:spChg>
-        <pc:spChg chg="mod">
-          <ac:chgData name="Shivam Singh" userId="e52e9ba4b5bcdf08" providerId="LiveId" clId="{341AFF7A-C5CD-4491-9020-97A9030EB6ED}" dt="2026-08-15T06:31:48.831" v="1" actId="26606"/>
-          <ac:spMkLst>
-            <pc:docMk/>
-            <pc:sldMk cId="0" sldId="269"/>
-            <ac:spMk id="21" creationId="{00000000-0000-0000-0000-000000000000}"/>
-          </ac:spMkLst>
-        </pc:spChg>
-        <pc:spChg chg="mod">
-          <ac:chgData name="Shivam Singh" userId="e52e9ba4b5bcdf08" providerId="LiveId" clId="{341AFF7A-C5CD-4491-9020-97A9030EB6ED}" dt="2026-08-15T06:31:48.831" v="1" actId="26606"/>
-          <ac:spMkLst>
-            <pc:docMk/>
-            <pc:sldMk cId="0" sldId="269"/>
-            <ac:spMk id="24" creationId="{00000000-0000-0000-0000-000000000000}"/>
-          </ac:spMkLst>
-        </pc:spChg>
-        <pc:spChg chg="mod">
-          <ac:chgData name="Shivam Singh" userId="e52e9ba4b5bcdf08" providerId="LiveId" clId="{341AFF7A-C5CD-4491-9020-97A9030EB6ED}" dt="2026-08-15T06:31:48.831" v="1" actId="26606"/>
-          <ac:spMkLst>
-            <pc:docMk/>
-            <pc:sldMk cId="0" sldId="269"/>
-            <ac:spMk id="27" creationId="{00000000-0000-0000-0000-000000000000}"/>
-          </ac:spMkLst>
-        </pc:spChg>
-        <pc:spChg chg="del">
-          <ac:chgData name="Shivam Singh" userId="e52e9ba4b5bcdf08" providerId="LiveId" clId="{341AFF7A-C5CD-4491-9020-97A9030EB6ED}" dt="2026-08-15T06:31:48.831" v="1" actId="26606"/>
-          <ac:spMkLst>
-            <pc:docMk/>
-            <pc:sldMk cId="0" sldId="269"/>
-            <ac:spMk id="32" creationId="{00000000-0000-0000-0000-000000000000}"/>
-          </ac:spMkLst>
-        </pc:spChg>
-        <pc:spChg chg="del">
-          <ac:chgData name="Shivam Singh" userId="e52e9ba4b5bcdf08" providerId="LiveId" clId="{341AFF7A-C5CD-4491-9020-97A9030EB6ED}" dt="2026-08-15T06:31:48.831" v="1" actId="26606"/>
-          <ac:spMkLst>
-            <pc:docMk/>
-            <pc:sldMk cId="0" sldId="269"/>
-            <ac:spMk id="57" creationId="{00000000-0000-0000-0000-000000000000}"/>
-          </ac:spMkLst>
-        </pc:spChg>
-        <pc:spChg chg="mod replId">
-          <ac:chgData name="Shivam Singh" userId="e52e9ba4b5bcdf08" providerId="LiveId" clId="{341AFF7A-C5CD-4491-9020-97A9030EB6ED}" dt="2026-08-15T06:31:47.763" v="0" actId="26606"/>
-          <ac:spMkLst>
-            <pc:docMk/>
-            <pc:sldMk cId="0" sldId="269"/>
-            <ac:spMk id="60" creationId="{00000000-0000-0000-0000-000000000000}"/>
-          </ac:spMkLst>
-        </pc:spChg>
-        <pc:picChg chg="mod replId">
-          <ac:chgData name="Shivam Singh" userId="e52e9ba4b5bcdf08" providerId="LiveId" clId="{341AFF7A-C5CD-4491-9020-97A9030EB6ED}" dt="2026-08-15T06:31:47.763" v="0" actId="26606"/>
-          <ac:picMkLst>
-            <pc:docMk/>
-            <pc:sldMk cId="0" sldId="269"/>
-            <ac:picMk id="59" creationId="{00000000-0000-0000-0000-000000000000}"/>
-          </ac:picMkLst>
-        </pc:picChg>
-      </pc:sldChg>
-      <pc:sldChg chg="addSp delSp modSp del mod ord">
-        <pc:chgData name="Shivam Singh" userId="e52e9ba4b5bcdf08" providerId="LiveId" clId="{341AFF7A-C5CD-4491-9020-97A9030EB6ED}" dt="2026-08-15T06:56:09.641" v="221" actId="47"/>
-        <pc:sldMkLst>
-          <pc:docMk/>
-          <pc:sldMk cId="0" sldId="270"/>
-        </pc:sldMkLst>
-        <pc:spChg chg="del mod">
-          <ac:chgData name="Shivam Singh" userId="e52e9ba4b5bcdf08" providerId="LiveId" clId="{341AFF7A-C5CD-4491-9020-97A9030EB6ED}" dt="2026-08-15T06:55:22.985" v="192"/>
-          <ac:spMkLst>
-            <pc:docMk/>
-            <pc:sldMk cId="0" sldId="270"/>
-            <ac:spMk id="2" creationId="{00000000-0000-0000-0000-000000000000}"/>
-          </ac:spMkLst>
-        </pc:spChg>
-        <pc:spChg chg="mod">
-          <ac:chgData name="Shivam Singh" userId="e52e9ba4b5bcdf08" providerId="LiveId" clId="{341AFF7A-C5CD-4491-9020-97A9030EB6ED}" dt="2026-08-15T06:31:48.831" v="1" actId="26606"/>
-          <ac:spMkLst>
-            <pc:docMk/>
-            <pc:sldMk cId="0" sldId="270"/>
-            <ac:spMk id="3" creationId="{00000000-0000-0000-0000-000000000000}"/>
-          </ac:spMkLst>
-        </pc:spChg>
-        <pc:spChg chg="del mod">
-          <ac:chgData name="Shivam Singh" userId="e52e9ba4b5bcdf08" providerId="LiveId" clId="{341AFF7A-C5CD-4491-9020-97A9030EB6ED}" dt="2026-08-15T06:53:35.768" v="159"/>
-          <ac:spMkLst>
-            <pc:docMk/>
-            <pc:sldMk cId="0" sldId="270"/>
-            <ac:spMk id="4" creationId="{00000000-0000-0000-0000-000000000000}"/>
-          </ac:spMkLst>
-        </pc:spChg>
-        <pc:spChg chg="del">
-          <ac:chgData name="Shivam Singh" userId="e52e9ba4b5bcdf08" providerId="LiveId" clId="{341AFF7A-C5CD-4491-9020-97A9030EB6ED}" dt="2026-08-15T06:54:11.462" v="163" actId="21"/>
-          <ac:spMkLst>
-            <pc:docMk/>
-            <pc:sldMk cId="0" sldId="270"/>
-            <ac:spMk id="7" creationId="{00000000-0000-0000-0000-000000000000}"/>
-          </ac:spMkLst>
-        </pc:spChg>
-        <pc:spChg chg="del mod">
-          <ac:chgData name="Shivam Singh" userId="e52e9ba4b5bcdf08" providerId="LiveId" clId="{341AFF7A-C5CD-4491-9020-97A9030EB6ED}" dt="2026-08-15T06:54:11.462" v="163" actId="21"/>
-          <ac:spMkLst>
-            <pc:docMk/>
-            <pc:sldMk cId="0" sldId="270"/>
-            <ac:spMk id="8" creationId="{00000000-0000-0000-0000-000000000000}"/>
-          </ac:spMkLst>
-        </pc:spChg>
-        <pc:spChg chg="del mod">
-          <ac:chgData name="Shivam Singh" userId="e52e9ba4b5bcdf08" providerId="LiveId" clId="{341AFF7A-C5CD-4491-9020-97A9030EB6ED}" dt="2026-08-15T06:54:11.462" v="163" actId="21"/>
-          <ac:spMkLst>
-            <pc:docMk/>
-            <pc:sldMk cId="0" sldId="270"/>
-            <ac:spMk id="9" creationId="{00000000-0000-0000-0000-000000000000}"/>
-          </ac:spMkLst>
-        </pc:spChg>
-        <pc:spChg chg="del">
-          <ac:chgData name="Shivam Singh" userId="e52e9ba4b5bcdf08" providerId="LiveId" clId="{341AFF7A-C5CD-4491-9020-97A9030EB6ED}" dt="2026-08-15T06:54:11.462" v="163" actId="21"/>
-          <ac:spMkLst>
-            <pc:docMk/>
-            <pc:sldMk cId="0" sldId="270"/>
-            <ac:spMk id="10" creationId="{00000000-0000-0000-0000-000000000000}"/>
-          </ac:spMkLst>
-        </pc:spChg>
-        <pc:spChg chg="del">
-          <ac:chgData name="Shivam Singh" userId="e52e9ba4b5bcdf08" providerId="LiveId" clId="{341AFF7A-C5CD-4491-9020-97A9030EB6ED}" dt="2026-08-15T06:54:11.462" v="163" actId="21"/>
-          <ac:spMkLst>
-            <pc:docMk/>
-            <pc:sldMk cId="0" sldId="270"/>
-            <ac:spMk id="11" creationId="{00000000-0000-0000-0000-000000000000}"/>
-          </ac:spMkLst>
-        </pc:spChg>
-        <pc:spChg chg="del mod">
-          <ac:chgData name="Shivam Singh" userId="e52e9ba4b5bcdf08" providerId="LiveId" clId="{341AFF7A-C5CD-4491-9020-97A9030EB6ED}" dt="2026-08-15T06:54:11.462" v="163" actId="21"/>
-          <ac:spMkLst>
-            <pc:docMk/>
-            <pc:sldMk cId="0" sldId="270"/>
-            <ac:spMk id="12" creationId="{00000000-0000-0000-0000-000000000000}"/>
-          </ac:spMkLst>
-        </pc:spChg>
-        <pc:spChg chg="del">
-          <ac:chgData name="Shivam Singh" userId="e52e9ba4b5bcdf08" providerId="LiveId" clId="{341AFF7A-C5CD-4491-9020-97A9030EB6ED}" dt="2026-08-15T06:54:11.462" v="163" actId="21"/>
-          <ac:spMkLst>
-            <pc:docMk/>
-            <pc:sldMk cId="0" sldId="270"/>
-            <ac:spMk id="13" creationId="{00000000-0000-0000-0000-000000000000}"/>
-          </ac:spMkLst>
-        </pc:spChg>
-        <pc:spChg chg="mod">
-          <ac:chgData name="Shivam Singh" userId="e52e9ba4b5bcdf08" providerId="LiveId" clId="{341AFF7A-C5CD-4491-9020-97A9030EB6ED}" dt="2026-08-15T06:52:05.400" v="139" actId="26606"/>
-          <ac:spMkLst>
-            <pc:docMk/>
-            <pc:sldMk cId="0" sldId="270"/>
-            <ac:spMk id="14" creationId="{00000000-0000-0000-0000-000000000000}"/>
-          </ac:spMkLst>
-        </pc:spChg>
-        <pc:spChg chg="del">
-          <ac:chgData name="Shivam Singh" userId="e52e9ba4b5bcdf08" providerId="LiveId" clId="{341AFF7A-C5CD-4491-9020-97A9030EB6ED}" dt="2026-08-15T06:54:11.462" v="163" actId="21"/>
-          <ac:spMkLst>
-            <pc:docMk/>
-            <pc:sldMk cId="0" sldId="270"/>
-            <ac:spMk id="15" creationId="{00000000-0000-0000-0000-000000000000}"/>
-          </ac:spMkLst>
-        </pc:spChg>
-        <pc:spChg chg="del mod">
-          <ac:chgData name="Shivam Singh" userId="e52e9ba4b5bcdf08" providerId="LiveId" clId="{341AFF7A-C5CD-4491-9020-97A9030EB6ED}" dt="2026-08-15T06:54:11.462" v="163" actId="21"/>
-          <ac:spMkLst>
-            <pc:docMk/>
-            <pc:sldMk cId="0" sldId="270"/>
-            <ac:spMk id="17" creationId="{00000000-0000-0000-0000-000000000000}"/>
-          </ac:spMkLst>
-        </pc:spChg>
-        <pc:spChg chg="del mod">
-          <ac:chgData name="Shivam Singh" userId="e52e9ba4b5bcdf08" providerId="LiveId" clId="{341AFF7A-C5CD-4491-9020-97A9030EB6ED}" dt="2026-08-15T06:54:11.462" v="163" actId="21"/>
-          <ac:spMkLst>
-            <pc:docMk/>
-            <pc:sldMk cId="0" sldId="270"/>
-            <ac:spMk id="18" creationId="{00000000-0000-0000-0000-000000000000}"/>
-          </ac:spMkLst>
-        </pc:spChg>
-        <pc:spChg chg="del">
-          <ac:chgData name="Shivam Singh" userId="e52e9ba4b5bcdf08" providerId="LiveId" clId="{341AFF7A-C5CD-4491-9020-97A9030EB6ED}" dt="2026-08-15T06:31:48.831" v="1" actId="26606"/>
-          <ac:spMkLst>
-            <pc:docMk/>
-            <pc:sldMk cId="0" sldId="270"/>
-            <ac:spMk id="20" creationId="{00000000-0000-0000-0000-000000000000}"/>
-          </ac:spMkLst>
-        </pc:spChg>
-        <pc:spChg chg="del">
-          <ac:chgData name="Shivam Singh" userId="e52e9ba4b5bcdf08" providerId="LiveId" clId="{341AFF7A-C5CD-4491-9020-97A9030EB6ED}" dt="2026-08-15T06:31:48.831" v="1" actId="26606"/>
-          <ac:spMkLst>
-            <pc:docMk/>
-            <pc:sldMk cId="0" sldId="270"/>
-            <ac:spMk id="21" creationId="{00000000-0000-0000-0000-000000000000}"/>
-          </ac:spMkLst>
-        </pc:spChg>
-        <pc:spChg chg="mod replId">
-          <ac:chgData name="Shivam Singh" userId="e52e9ba4b5bcdf08" providerId="LiveId" clId="{341AFF7A-C5CD-4491-9020-97A9030EB6ED}" dt="2026-08-15T06:31:47.763" v="0" actId="26606"/>
-          <ac:spMkLst>
-            <pc:docMk/>
-            <pc:sldMk cId="0" sldId="270"/>
-            <ac:spMk id="31" creationId="{00000000-0000-0000-0000-000000000000}"/>
-          </ac:spMkLst>
-        </pc:spChg>
-        <pc:spChg chg="del mod replId">
-          <ac:chgData name="Shivam Singh" userId="e52e9ba4b5bcdf08" providerId="LiveId" clId="{341AFF7A-C5CD-4491-9020-97A9030EB6ED}" dt="2026-08-15T06:31:48.831" v="1" actId="26606"/>
-          <ac:spMkLst>
-            <pc:docMk/>
-            <pc:sldMk cId="0" sldId="270"/>
-            <ac:spMk id="32" creationId="{00000000-0000-0000-0000-000000000000}"/>
-          </ac:spMkLst>
-        </pc:spChg>
-        <pc:spChg chg="del mod replId">
-          <ac:chgData name="Shivam Singh" userId="e52e9ba4b5bcdf08" providerId="LiveId" clId="{341AFF7A-C5CD-4491-9020-97A9030EB6ED}" dt="2026-08-15T06:31:48.831" v="1" actId="26606"/>
-          <ac:spMkLst>
-            <pc:docMk/>
-            <pc:sldMk cId="0" sldId="270"/>
-            <ac:spMk id="33" creationId="{00000000-0000-0000-0000-000000000000}"/>
-          </ac:spMkLst>
-        </pc:spChg>
-      </pc:sldChg>
-      <pc:sldChg chg="addSp delSp modSp mod">
-        <pc:chgData name="Shivam Singh" userId="e52e9ba4b5bcdf08" providerId="LiveId" clId="{341AFF7A-C5CD-4491-9020-97A9030EB6ED}" dt="2026-08-15T06:52:05.400" v="139" actId="26606"/>
-        <pc:sldMkLst>
-          <pc:docMk/>
-          <pc:sldMk cId="0" sldId="271"/>
-        </pc:sldMkLst>
-        <pc:spChg chg="mod">
-          <ac:chgData name="Shivam Singh" userId="e52e9ba4b5bcdf08" providerId="LiveId" clId="{341AFF7A-C5CD-4491-9020-97A9030EB6ED}" dt="2026-08-15T06:31:48.831" v="1" actId="26606"/>
-          <ac:spMkLst>
-            <pc:docMk/>
-            <pc:sldMk cId="0" sldId="271"/>
-            <ac:spMk id="4" creationId="{00000000-0000-0000-0000-000000000000}"/>
-          </ac:spMkLst>
-        </pc:spChg>
-        <pc:spChg chg="mod">
-          <ac:chgData name="Shivam Singh" userId="e52e9ba4b5bcdf08" providerId="LiveId" clId="{341AFF7A-C5CD-4491-9020-97A9030EB6ED}" dt="2026-08-15T06:31:48.831" v="1" actId="26606"/>
-          <ac:spMkLst>
-            <pc:docMk/>
-            <pc:sldMk cId="0" sldId="271"/>
-            <ac:spMk id="7" creationId="{00000000-0000-0000-0000-000000000000}"/>
-          </ac:spMkLst>
-        </pc:spChg>
-        <pc:spChg chg="mod">
-          <ac:chgData name="Shivam Singh" userId="e52e9ba4b5bcdf08" providerId="LiveId" clId="{341AFF7A-C5CD-4491-9020-97A9030EB6ED}" dt="2026-08-15T06:31:48.831" v="1" actId="26606"/>
-          <ac:spMkLst>
-            <pc:docMk/>
-            <pc:sldMk cId="0" sldId="271"/>
-            <ac:spMk id="8" creationId="{00000000-0000-0000-0000-000000000000}"/>
-          </ac:spMkLst>
-        </pc:spChg>
-        <pc:spChg chg="mod">
-          <ac:chgData name="Shivam Singh" userId="e52e9ba4b5bcdf08" providerId="LiveId" clId="{341AFF7A-C5CD-4491-9020-97A9030EB6ED}" dt="2026-08-15T06:31:48.831" v="1" actId="26606"/>
-          <ac:spMkLst>
-            <pc:docMk/>
-            <pc:sldMk cId="0" sldId="271"/>
-            <ac:spMk id="9" creationId="{00000000-0000-0000-0000-000000000000}"/>
-          </ac:spMkLst>
-        </pc:spChg>
-        <pc:spChg chg="mod">
-          <ac:chgData name="Shivam Singh" userId="e52e9ba4b5bcdf08" providerId="LiveId" clId="{341AFF7A-C5CD-4491-9020-97A9030EB6ED}" dt="2026-08-15T06:31:48.831" v="1" actId="26606"/>
-          <ac:spMkLst>
-            <pc:docMk/>
-            <pc:sldMk cId="0" sldId="271"/>
-            <ac:spMk id="12" creationId="{00000000-0000-0000-0000-000000000000}"/>
-          </ac:spMkLst>
-        </pc:spChg>
-        <pc:spChg chg="mod">
-          <ac:chgData name="Shivam Singh" userId="e52e9ba4b5bcdf08" providerId="LiveId" clId="{341AFF7A-C5CD-4491-9020-97A9030EB6ED}" dt="2026-08-15T06:31:48.831" v="1" actId="26606"/>
-          <ac:spMkLst>
-            <pc:docMk/>
-            <pc:sldMk cId="0" sldId="271"/>
-            <ac:spMk id="16" creationId="{00000000-0000-0000-0000-000000000000}"/>
-          </ac:spMkLst>
-        </pc:spChg>
-        <pc:spChg chg="mod">
-          <ac:chgData name="Shivam Singh" userId="e52e9ba4b5bcdf08" providerId="LiveId" clId="{341AFF7A-C5CD-4491-9020-97A9030EB6ED}" dt="2026-08-15T06:31:48.831" v="1" actId="26606"/>
-          <ac:spMkLst>
-            <pc:docMk/>
-            <pc:sldMk cId="0" sldId="271"/>
-            <ac:spMk id="17" creationId="{00000000-0000-0000-0000-000000000000}"/>
-          </ac:spMkLst>
-        </pc:spChg>
-        <pc:spChg chg="add">
-          <ac:chgData name="Shivam Singh" userId="e52e9ba4b5bcdf08" providerId="LiveId" clId="{341AFF7A-C5CD-4491-9020-97A9030EB6ED}" dt="2026-08-15T06:31:48.831" v="1" actId="26606"/>
-          <ac:spMkLst>
-            <pc:docMk/>
-            <pc:sldMk cId="0" sldId="271"/>
-            <ac:spMk id="21" creationId="{00000000-0000-0000-0000-000000000000}"/>
-          </ac:spMkLst>
-        </pc:spChg>
-        <pc:spChg chg="mod">
-          <ac:chgData name="Shivam Singh" userId="e52e9ba4b5bcdf08" providerId="LiveId" clId="{341AFF7A-C5CD-4491-9020-97A9030EB6ED}" dt="2026-08-15T06:52:05.400" v="139" actId="26606"/>
-          <ac:spMkLst>
-            <pc:docMk/>
-            <pc:sldMk cId="0" sldId="271"/>
-            <ac:spMk id="26" creationId="{00000000-0000-0000-0000-000000000000}"/>
-          </ac:spMkLst>
-        </pc:spChg>
-        <pc:spChg chg="add">
-          <ac:chgData name="Shivam Singh" userId="e52e9ba4b5bcdf08" providerId="LiveId" clId="{341AFF7A-C5CD-4491-9020-97A9030EB6ED}" dt="2026-08-15T06:31:48.831" v="1" actId="26606"/>
-          <ac:spMkLst>
-            <pc:docMk/>
-            <pc:sldMk cId="0" sldId="271"/>
-            <ac:spMk id="27" creationId="{00000000-0000-0000-0000-000000000000}"/>
-          </ac:spMkLst>
-        </pc:spChg>
-        <pc:spChg chg="mod">
-          <ac:chgData name="Shivam Singh" userId="e52e9ba4b5bcdf08" providerId="LiveId" clId="{341AFF7A-C5CD-4491-9020-97A9030EB6ED}" dt="2026-08-15T06:52:05.400" v="139" actId="26606"/>
-          <ac:spMkLst>
-            <pc:docMk/>
-            <pc:sldMk cId="0" sldId="271"/>
-            <ac:spMk id="30" creationId="{00000000-0000-0000-0000-000000000000}"/>
-          </ac:spMkLst>
-        </pc:spChg>
-        <pc:spChg chg="mod replId">
-          <ac:chgData name="Shivam Singh" userId="e52e9ba4b5bcdf08" providerId="LiveId" clId="{341AFF7A-C5CD-4491-9020-97A9030EB6ED}" dt="2026-08-15T06:31:47.763" v="0" actId="26606"/>
-          <ac:spMkLst>
-            <pc:docMk/>
-            <pc:sldMk cId="0" sldId="271"/>
-            <ac:spMk id="31" creationId="{00000000-0000-0000-0000-000000000000}"/>
-          </ac:spMkLst>
-        </pc:spChg>
-        <pc:spChg chg="mod replId">
-          <ac:chgData name="Shivam Singh" userId="e52e9ba4b5bcdf08" providerId="LiveId" clId="{341AFF7A-C5CD-4491-9020-97A9030EB6ED}" dt="2026-08-15T06:31:47.763" v="0" actId="26606"/>
-          <ac:spMkLst>
-            <pc:docMk/>
-            <pc:sldMk cId="0" sldId="271"/>
-            <ac:spMk id="32" creationId="{00000000-0000-0000-0000-000000000000}"/>
-          </ac:spMkLst>
-        </pc:spChg>
-        <pc:spChg chg="del mod replId">
-          <ac:chgData name="Shivam Singh" userId="e52e9ba4b5bcdf08" providerId="LiveId" clId="{341AFF7A-C5CD-4491-9020-97A9030EB6ED}" dt="2026-08-15T06:31:48.831" v="1" actId="26606"/>
-          <ac:spMkLst>
-            <pc:docMk/>
-            <pc:sldMk cId="0" sldId="271"/>
-            <ac:spMk id="33" creationId="{00000000-0000-0000-0000-000000000000}"/>
-          </ac:spMkLst>
-        </pc:spChg>
-        <pc:picChg chg="mod replId">
-          <ac:chgData name="Shivam Singh" userId="e52e9ba4b5bcdf08" providerId="LiveId" clId="{341AFF7A-C5CD-4491-9020-97A9030EB6ED}" dt="2026-08-15T06:31:47.763" v="0" actId="26606"/>
-          <ac:picMkLst>
-            <pc:docMk/>
-            <pc:sldMk cId="0" sldId="271"/>
-            <ac:picMk id="34" creationId="{00000000-0000-0000-0000-000000000000}"/>
-          </ac:picMkLst>
-        </pc:picChg>
-      </pc:sldChg>
-      <pc:sldChg chg="addSp delSp modSp del mod ord">
-        <pc:chgData name="Shivam Singh" userId="e52e9ba4b5bcdf08" providerId="LiveId" clId="{341AFF7A-C5CD-4491-9020-97A9030EB6ED}" dt="2026-08-15T06:41:07.439" v="79" actId="2696"/>
-        <pc:sldMkLst>
-          <pc:docMk/>
-          <pc:sldMk cId="0" sldId="274"/>
-        </pc:sldMkLst>
-        <pc:spChg chg="mod">
-          <ac:chgData name="Shivam Singh" userId="e52e9ba4b5bcdf08" providerId="LiveId" clId="{341AFF7A-C5CD-4491-9020-97A9030EB6ED}" dt="2026-08-15T06:38:08.464" v="61"/>
-          <ac:spMkLst>
-            <pc:docMk/>
-            <pc:sldMk cId="0" sldId="274"/>
-            <ac:spMk id="2" creationId="{00000000-0000-0000-0000-000000000000}"/>
-          </ac:spMkLst>
-        </pc:spChg>
-        <pc:spChg chg="mod">
-          <ac:chgData name="Shivam Singh" userId="e52e9ba4b5bcdf08" providerId="LiveId" clId="{341AFF7A-C5CD-4491-9020-97A9030EB6ED}" dt="2026-08-15T06:31:48.831" v="1" actId="26606"/>
-          <ac:spMkLst>
-            <pc:docMk/>
-            <pc:sldMk cId="0" sldId="274"/>
-            <ac:spMk id="7" creationId="{00000000-0000-0000-0000-000000000000}"/>
-          </ac:spMkLst>
-        </pc:spChg>
-        <pc:spChg chg="mod">
-          <ac:chgData name="Shivam Singh" userId="e52e9ba4b5bcdf08" providerId="LiveId" clId="{341AFF7A-C5CD-4491-9020-97A9030EB6ED}" dt="2026-08-15T06:31:48.831" v="1" actId="26606"/>
-          <ac:spMkLst>
-            <pc:docMk/>
-            <pc:sldMk cId="0" sldId="274"/>
-            <ac:spMk id="12" creationId="{00000000-0000-0000-0000-000000000000}"/>
-          </ac:spMkLst>
-        </pc:spChg>
-        <pc:spChg chg="mod">
-          <ac:chgData name="Shivam Singh" userId="e52e9ba4b5bcdf08" providerId="LiveId" clId="{341AFF7A-C5CD-4491-9020-97A9030EB6ED}" dt="2026-08-15T06:31:48.831" v="1" actId="26606"/>
-          <ac:spMkLst>
-            <pc:docMk/>
-            <pc:sldMk cId="0" sldId="274"/>
-            <ac:spMk id="13" creationId="{00000000-0000-0000-0000-000000000000}"/>
-          </ac:spMkLst>
-        </pc:spChg>
-        <pc:spChg chg="mod">
-          <ac:chgData name="Shivam Singh" userId="e52e9ba4b5bcdf08" providerId="LiveId" clId="{341AFF7A-C5CD-4491-9020-97A9030EB6ED}" dt="2026-08-15T06:31:48.831" v="1" actId="26606"/>
-          <ac:spMkLst>
-            <pc:docMk/>
-            <pc:sldMk cId="0" sldId="274"/>
-            <ac:spMk id="15" creationId="{00000000-0000-0000-0000-000000000000}"/>
-          </ac:spMkLst>
-        </pc:spChg>
-        <pc:spChg chg="mod">
-          <ac:chgData name="Shivam Singh" userId="e52e9ba4b5bcdf08" providerId="LiveId" clId="{341AFF7A-C5CD-4491-9020-97A9030EB6ED}" dt="2026-08-15T06:31:48.831" v="1" actId="26606"/>
-          <ac:spMkLst>
-            <pc:docMk/>
-            <pc:sldMk cId="0" sldId="274"/>
-            <ac:spMk id="20" creationId="{00000000-0000-0000-0000-000000000000}"/>
-          </ac:spMkLst>
-        </pc:spChg>
-        <pc:spChg chg="add">
-          <ac:chgData name="Shivam Singh" userId="e52e9ba4b5bcdf08" providerId="LiveId" clId="{341AFF7A-C5CD-4491-9020-97A9030EB6ED}" dt="2026-08-15T06:31:48.831" v="1" actId="26606"/>
-          <ac:spMkLst>
-            <pc:docMk/>
-            <pc:sldMk cId="0" sldId="274"/>
-            <ac:spMk id="23" creationId="{00000000-0000-0000-0000-000000000000}"/>
-          </ac:spMkLst>
-        </pc:spChg>
-        <pc:spChg chg="del mod replId">
-          <ac:chgData name="Shivam Singh" userId="e52e9ba4b5bcdf08" providerId="LiveId" clId="{341AFF7A-C5CD-4491-9020-97A9030EB6ED}" dt="2026-08-15T06:31:48.831" v="1" actId="26606"/>
-          <ac:spMkLst>
-            <pc:docMk/>
-            <pc:sldMk cId="0" sldId="274"/>
-            <ac:spMk id="24" creationId="{00000000-0000-0000-0000-000000000000}"/>
-          </ac:spMkLst>
-        </pc:spChg>
-        <pc:spChg chg="del mod replId">
-          <ac:chgData name="Shivam Singh" userId="e52e9ba4b5bcdf08" providerId="LiveId" clId="{341AFF7A-C5CD-4491-9020-97A9030EB6ED}" dt="2026-08-15T06:31:48.831" v="1" actId="26606"/>
-          <ac:spMkLst>
-            <pc:docMk/>
-            <pc:sldMk cId="0" sldId="274"/>
-            <ac:spMk id="25" creationId="{00000000-0000-0000-0000-000000000000}"/>
-          </ac:spMkLst>
-        </pc:spChg>
-        <pc:spChg chg="del mod replId">
-          <ac:chgData name="Shivam Singh" userId="e52e9ba4b5bcdf08" providerId="LiveId" clId="{341AFF7A-C5CD-4491-9020-97A9030EB6ED}" dt="2026-08-15T06:31:48.831" v="1" actId="26606"/>
-          <ac:spMkLst>
-            <pc:docMk/>
-            <pc:sldMk cId="0" sldId="274"/>
-            <ac:spMk id="26" creationId="{00000000-0000-0000-0000-000000000000}"/>
-          </ac:spMkLst>
-        </pc:spChg>
-        <pc:spChg chg="mod replId">
-          <ac:chgData name="Shivam Singh" userId="e52e9ba4b5bcdf08" providerId="LiveId" clId="{341AFF7A-C5CD-4491-9020-97A9030EB6ED}" dt="2026-08-15T06:31:47.763" v="0" actId="26606"/>
-          <ac:spMkLst>
-            <pc:docMk/>
-            <pc:sldMk cId="0" sldId="274"/>
-            <ac:spMk id="27" creationId="{00000000-0000-0000-0000-000000000000}"/>
-          </ac:spMkLst>
-        </pc:spChg>
-        <pc:spChg chg="del mod replId">
-          <ac:chgData name="Shivam Singh" userId="e52e9ba4b5bcdf08" providerId="LiveId" clId="{341AFF7A-C5CD-4491-9020-97A9030EB6ED}" dt="2026-08-15T06:31:48.831" v="1" actId="26606"/>
-          <ac:spMkLst>
-            <pc:docMk/>
-            <pc:sldMk cId="0" sldId="274"/>
-            <ac:spMk id="28" creationId="{00000000-0000-0000-0000-000000000000}"/>
-          </ac:spMkLst>
-        </pc:spChg>
-        <pc:spChg chg="mod replId">
-          <ac:chgData name="Shivam Singh" userId="e52e9ba4b5bcdf08" providerId="LiveId" clId="{341AFF7A-C5CD-4491-9020-97A9030EB6ED}" dt="2026-08-15T06:31:47.763" v="0" actId="26606"/>
-          <ac:spMkLst>
-            <pc:docMk/>
-            <pc:sldMk cId="0" sldId="274"/>
-            <ac:spMk id="29" creationId="{00000000-0000-0000-0000-000000000000}"/>
-          </ac:spMkLst>
-        </pc:spChg>
-        <pc:picChg chg="mod replId">
-          <ac:chgData name="Shivam Singh" userId="e52e9ba4b5bcdf08" providerId="LiveId" clId="{341AFF7A-C5CD-4491-9020-97A9030EB6ED}" dt="2026-08-15T06:31:47.763" v="0" actId="26606"/>
-          <ac:picMkLst>
-            <pc:docMk/>
-            <pc:sldMk cId="0" sldId="274"/>
-            <ac:picMk id="30" creationId="{00000000-0000-0000-0000-000000000000}"/>
-          </ac:picMkLst>
-        </pc:picChg>
-      </pc:sldChg>
-      <pc:sldChg chg="modSp add mod ord">
-        <pc:chgData name="Shivam Singh" userId="e52e9ba4b5bcdf08" providerId="LiveId" clId="{341AFF7A-C5CD-4491-9020-97A9030EB6ED}" dt="2026-08-15T06:52:05.400" v="139" actId="26606"/>
-        <pc:sldMkLst>
-          <pc:docMk/>
-          <pc:sldMk cId="2264175142" sldId="274"/>
-        </pc:sldMkLst>
-        <pc:spChg chg="mod">
-          <ac:chgData name="Shivam Singh" userId="e52e9ba4b5bcdf08" providerId="LiveId" clId="{341AFF7A-C5CD-4491-9020-97A9030EB6ED}" dt="2026-08-15T06:52:05.400" v="139" actId="26606"/>
-          <ac:spMkLst>
-            <pc:docMk/>
-            <pc:sldMk cId="2264175142" sldId="274"/>
-            <ac:spMk id="2" creationId="{AF079B91-0EF1-C1A2-BF56-9AD1FD92B8D1}"/>
-          </ac:spMkLst>
-        </pc:spChg>
-        <pc:spChg chg="mod">
-          <ac:chgData name="Shivam Singh" userId="e52e9ba4b5bcdf08" providerId="LiveId" clId="{341AFF7A-C5CD-4491-9020-97A9030EB6ED}" dt="2026-08-15T06:52:05.400" v="139" actId="26606"/>
-          <ac:spMkLst>
-            <pc:docMk/>
-            <pc:sldMk cId="2264175142" sldId="274"/>
-            <ac:spMk id="13" creationId="{A6BF47E0-F39A-0F0C-064D-4B093A6C4EDE}"/>
-          </ac:spMkLst>
-        </pc:spChg>
-        <pc:spChg chg="mod">
-          <ac:chgData name="Shivam Singh" userId="e52e9ba4b5bcdf08" providerId="LiveId" clId="{341AFF7A-C5CD-4491-9020-97A9030EB6ED}" dt="2026-08-15T06:52:05.400" v="139" actId="26606"/>
-          <ac:spMkLst>
-            <pc:docMk/>
-            <pc:sldMk cId="2264175142" sldId="274"/>
-            <ac:spMk id="19" creationId="{8BEB4986-D3EF-FF51-05EB-72D9503CF6DE}"/>
-          </ac:spMkLst>
-        </pc:spChg>
-        <pc:spChg chg="mod">
-          <ac:chgData name="Shivam Singh" userId="e52e9ba4b5bcdf08" providerId="LiveId" clId="{341AFF7A-C5CD-4491-9020-97A9030EB6ED}" dt="2026-08-15T06:52:05.400" v="139" actId="26606"/>
-          <ac:spMkLst>
-            <pc:docMk/>
-            <pc:sldMk cId="2264175142" sldId="274"/>
-            <ac:spMk id="22" creationId="{DD72489A-3865-30BD-07ED-838FB57B11E2}"/>
-          </ac:spMkLst>
-        </pc:spChg>
-        <pc:spChg chg="mod">
-          <ac:chgData name="Shivam Singh" userId="e52e9ba4b5bcdf08" providerId="LiveId" clId="{341AFF7A-C5CD-4491-9020-97A9030EB6ED}" dt="2026-08-15T06:52:05.400" v="139" actId="26606"/>
-          <ac:spMkLst>
-            <pc:docMk/>
-            <pc:sldMk cId="2264175142" sldId="274"/>
-            <ac:spMk id="23" creationId="{A6ED1FCF-8E3A-3247-5B82-88E73BF909A2}"/>
-          </ac:spMkLst>
-        </pc:spChg>
-      </pc:sldChg>
-      <pc:sldChg chg="add del setBg">
-        <pc:chgData name="Shivam Singh" userId="e52e9ba4b5bcdf08" providerId="LiveId" clId="{341AFF7A-C5CD-4491-9020-97A9030EB6ED}" dt="2026-08-15T06:41:18.800" v="81"/>
-        <pc:sldMkLst>
-          <pc:docMk/>
-          <pc:sldMk cId="3839552154" sldId="274"/>
-        </pc:sldMkLst>
-      </pc:sldChg>
-      <pc:sldChg chg="add del setBg">
-        <pc:chgData name="Shivam Singh" userId="e52e9ba4b5bcdf08" providerId="LiveId" clId="{341AFF7A-C5CD-4491-9020-97A9030EB6ED}" dt="2026-08-15T06:41:22.616" v="83"/>
-        <pc:sldMkLst>
-          <pc:docMk/>
-          <pc:sldMk cId="3873408188" sldId="274"/>
-        </pc:sldMkLst>
-      </pc:sldChg>
-      <pc:sldChg chg="addSp delSp modSp mod ord setBg">
-        <pc:chgData name="Shivam Singh" userId="e52e9ba4b5bcdf08" providerId="LiveId" clId="{341AFF7A-C5CD-4491-9020-97A9030EB6ED}" dt="2026-08-15T06:52:05.400" v="139" actId="26606"/>
-        <pc:sldMkLst>
-          <pc:docMk/>
-          <pc:sldMk cId="0" sldId="275"/>
-        </pc:sldMkLst>
-        <pc:spChg chg="mod">
-          <ac:chgData name="Shivam Singh" userId="e52e9ba4b5bcdf08" providerId="LiveId" clId="{341AFF7A-C5CD-4491-9020-97A9030EB6ED}" dt="2026-08-15T06:52:05.400" v="139" actId="26606"/>
-          <ac:spMkLst>
-            <pc:docMk/>
-            <pc:sldMk cId="0" sldId="275"/>
-            <ac:spMk id="2" creationId="{00000000-0000-0000-0000-000000000000}"/>
-          </ac:spMkLst>
-        </pc:spChg>
-        <pc:spChg chg="mod">
-          <ac:chgData name="Shivam Singh" userId="e52e9ba4b5bcdf08" providerId="LiveId" clId="{341AFF7A-C5CD-4491-9020-97A9030EB6ED}" dt="2026-08-15T06:31:48.831" v="1" actId="26606"/>
-          <ac:spMkLst>
-            <pc:docMk/>
-            <pc:sldMk cId="0" sldId="275"/>
-            <ac:spMk id="3" creationId="{00000000-0000-0000-0000-000000000000}"/>
-          </ac:spMkLst>
-        </pc:spChg>
-        <pc:spChg chg="mod">
-          <ac:chgData name="Shivam Singh" userId="e52e9ba4b5bcdf08" providerId="LiveId" clId="{341AFF7A-C5CD-4491-9020-97A9030EB6ED}" dt="2026-08-15T06:31:48.831" v="1" actId="26606"/>
-          <ac:spMkLst>
-            <pc:docMk/>
-            <pc:sldMk cId="0" sldId="275"/>
-            <ac:spMk id="4" creationId="{00000000-0000-0000-0000-000000000000}"/>
-          </ac:spMkLst>
-        </pc:spChg>
-        <pc:spChg chg="mod">
-          <ac:chgData name="Shivam Singh" userId="e52e9ba4b5bcdf08" providerId="LiveId" clId="{341AFF7A-C5CD-4491-9020-97A9030EB6ED}" dt="2026-08-15T06:31:48.831" v="1" actId="26606"/>
-          <ac:spMkLst>
-            <pc:docMk/>
-            <pc:sldMk cId="0" sldId="275"/>
-            <ac:spMk id="8" creationId="{00000000-0000-0000-0000-000000000000}"/>
-          </ac:spMkLst>
-        </pc:spChg>
-        <pc:spChg chg="mod">
-          <ac:chgData name="Shivam Singh" userId="e52e9ba4b5bcdf08" providerId="LiveId" clId="{341AFF7A-C5CD-4491-9020-97A9030EB6ED}" dt="2026-08-15T06:31:48.831" v="1" actId="26606"/>
-          <ac:spMkLst>
-            <pc:docMk/>
-            <pc:sldMk cId="0" sldId="275"/>
-            <ac:spMk id="10" creationId="{00000000-0000-0000-0000-000000000000}"/>
-          </ac:spMkLst>
-        </pc:spChg>
-        <pc:spChg chg="mod">
-          <ac:chgData name="Shivam Singh" userId="e52e9ba4b5bcdf08" providerId="LiveId" clId="{341AFF7A-C5CD-4491-9020-97A9030EB6ED}" dt="2026-08-15T06:52:05.400" v="139" actId="26606"/>
-          <ac:spMkLst>
-            <pc:docMk/>
-            <pc:sldMk cId="0" sldId="275"/>
-            <ac:spMk id="19" creationId="{00000000-0000-0000-0000-000000000000}"/>
-          </ac:spMkLst>
-        </pc:spChg>
-        <pc:spChg chg="mod">
-          <ac:chgData name="Shivam Singh" userId="e52e9ba4b5bcdf08" providerId="LiveId" clId="{341AFF7A-C5CD-4491-9020-97A9030EB6ED}" dt="2026-08-15T06:31:48.831" v="1" actId="26606"/>
-          <ac:spMkLst>
-            <pc:docMk/>
-            <pc:sldMk cId="0" sldId="275"/>
-            <ac:spMk id="22" creationId="{00000000-0000-0000-0000-000000000000}"/>
-          </ac:spMkLst>
-        </pc:spChg>
-        <pc:spChg chg="mod">
-          <ac:chgData name="Shivam Singh" userId="e52e9ba4b5bcdf08" providerId="LiveId" clId="{341AFF7A-C5CD-4491-9020-97A9030EB6ED}" dt="2026-08-15T06:31:48.831" v="1" actId="26606"/>
-          <ac:spMkLst>
-            <pc:docMk/>
-            <pc:sldMk cId="0" sldId="275"/>
-            <ac:spMk id="23" creationId="{00000000-0000-0000-0000-000000000000}"/>
-          </ac:spMkLst>
-        </pc:spChg>
-        <pc:spChg chg="mod">
-          <ac:chgData name="Shivam Singh" userId="e52e9ba4b5bcdf08" providerId="LiveId" clId="{341AFF7A-C5CD-4491-9020-97A9030EB6ED}" dt="2026-08-15T06:52:05.400" v="139" actId="26606"/>
-          <ac:spMkLst>
-            <pc:docMk/>
-            <pc:sldMk cId="0" sldId="275"/>
-            <ac:spMk id="26" creationId="{00000000-0000-0000-0000-000000000000}"/>
-          </ac:spMkLst>
-        </pc:spChg>
-        <pc:spChg chg="add mod">
-          <ac:chgData name="Shivam Singh" userId="e52e9ba4b5bcdf08" providerId="LiveId" clId="{341AFF7A-C5CD-4491-9020-97A9030EB6ED}" dt="2026-08-15T06:52:05.400" v="139" actId="26606"/>
-          <ac:spMkLst>
-            <pc:docMk/>
-            <pc:sldMk cId="0" sldId="275"/>
-            <ac:spMk id="30" creationId="{00000000-0000-0000-0000-000000000000}"/>
-          </ac:spMkLst>
-        </pc:spChg>
-        <pc:spChg chg="del mod replId">
-          <ac:chgData name="Shivam Singh" userId="e52e9ba4b5bcdf08" providerId="LiveId" clId="{341AFF7A-C5CD-4491-9020-97A9030EB6ED}" dt="2026-08-15T06:31:48.831" v="1" actId="26606"/>
-          <ac:spMkLst>
-            <pc:docMk/>
-            <pc:sldMk cId="0" sldId="275"/>
-            <ac:spMk id="31" creationId="{00000000-0000-0000-0000-000000000000}"/>
-          </ac:spMkLst>
-        </pc:spChg>
-        <pc:spChg chg="mod replId">
-          <ac:chgData name="Shivam Singh" userId="e52e9ba4b5bcdf08" providerId="LiveId" clId="{341AFF7A-C5CD-4491-9020-97A9030EB6ED}" dt="2026-08-15T06:31:47.763" v="0" actId="26606"/>
-          <ac:spMkLst>
-            <pc:docMk/>
-            <pc:sldMk cId="0" sldId="275"/>
-            <ac:spMk id="32" creationId="{00000000-0000-0000-0000-000000000000}"/>
-          </ac:spMkLst>
-        </pc:spChg>
-        <pc:spChg chg="del mod replId">
-          <ac:chgData name="Shivam Singh" userId="e52e9ba4b5bcdf08" providerId="LiveId" clId="{341AFF7A-C5CD-4491-9020-97A9030EB6ED}" dt="2026-08-15T06:31:48.831" v="1" actId="26606"/>
-          <ac:spMkLst>
-            <pc:docMk/>
-            <pc:sldMk cId="0" sldId="275"/>
-            <ac:spMk id="33" creationId="{00000000-0000-0000-0000-000000000000}"/>
-          </ac:spMkLst>
-        </pc:spChg>
-        <pc:spChg chg="mod replId">
-          <ac:chgData name="Shivam Singh" userId="e52e9ba4b5bcdf08" providerId="LiveId" clId="{341AFF7A-C5CD-4491-9020-97A9030EB6ED}" dt="2026-08-15T06:31:47.763" v="0" actId="26606"/>
-          <ac:spMkLst>
-            <pc:docMk/>
-            <pc:sldMk cId="0" sldId="275"/>
-            <ac:spMk id="34" creationId="{00000000-0000-0000-0000-000000000000}"/>
-          </ac:spMkLst>
-        </pc:spChg>
-        <pc:spChg chg="mod replId">
-          <ac:chgData name="Shivam Singh" userId="e52e9ba4b5bcdf08" providerId="LiveId" clId="{341AFF7A-C5CD-4491-9020-97A9030EB6ED}" dt="2026-08-15T06:31:47.763" v="0" actId="26606"/>
-          <ac:spMkLst>
-            <pc:docMk/>
-            <pc:sldMk cId="0" sldId="275"/>
-            <ac:spMk id="35" creationId="{00000000-0000-0000-0000-000000000000}"/>
-          </ac:spMkLst>
-        </pc:spChg>
-        <pc:spChg chg="mod replId">
-          <ac:chgData name="Shivam Singh" userId="e52e9ba4b5bcdf08" providerId="LiveId" clId="{341AFF7A-C5CD-4491-9020-97A9030EB6ED}" dt="2026-08-15T06:31:47.763" v="0" actId="26606"/>
-          <ac:spMkLst>
-            <pc:docMk/>
-            <pc:sldMk cId="0" sldId="275"/>
-            <ac:spMk id="36" creationId="{00000000-0000-0000-0000-000000000000}"/>
-          </ac:spMkLst>
-        </pc:spChg>
-        <pc:picChg chg="mod replId">
-          <ac:chgData name="Shivam Singh" userId="e52e9ba4b5bcdf08" providerId="LiveId" clId="{341AFF7A-C5CD-4491-9020-97A9030EB6ED}" dt="2026-08-15T06:31:47.763" v="0" actId="26606"/>
-          <ac:picMkLst>
-            <pc:docMk/>
-            <pc:sldMk cId="0" sldId="275"/>
-            <ac:picMk id="37" creationId="{00000000-0000-0000-0000-000000000000}"/>
-          </ac:picMkLst>
-        </pc:picChg>
-      </pc:sldChg>
-      <pc:sldChg chg="addSp delSp modSp mod ord setBg">
-        <pc:chgData name="Shivam Singh" userId="e52e9ba4b5bcdf08" providerId="LiveId" clId="{341AFF7A-C5CD-4491-9020-97A9030EB6ED}" dt="2026-08-15T06:52:05.400" v="139" actId="26606"/>
-        <pc:sldMkLst>
-          <pc:docMk/>
-          <pc:sldMk cId="0" sldId="278"/>
-        </pc:sldMkLst>
-        <pc:spChg chg="mod">
-          <ac:chgData name="Shivam Singh" userId="e52e9ba4b5bcdf08" providerId="LiveId" clId="{341AFF7A-C5CD-4491-9020-97A9030EB6ED}" dt="2026-08-15T06:52:05.400" v="139" actId="26606"/>
-          <ac:spMkLst>
-            <pc:docMk/>
-            <pc:sldMk cId="0" sldId="278"/>
-            <ac:spMk id="2" creationId="{00000000-0000-0000-0000-000000000000}"/>
-          </ac:spMkLst>
-        </pc:spChg>
-        <pc:spChg chg="mod">
-          <ac:chgData name="Shivam Singh" userId="e52e9ba4b5bcdf08" providerId="LiveId" clId="{341AFF7A-C5CD-4491-9020-97A9030EB6ED}" dt="2026-08-15T06:31:48.831" v="1" actId="26606"/>
-          <ac:spMkLst>
-            <pc:docMk/>
-            <pc:sldMk cId="0" sldId="278"/>
-            <ac:spMk id="7" creationId="{00000000-0000-0000-0000-000000000000}"/>
-          </ac:spMkLst>
-        </pc:spChg>
-        <pc:spChg chg="mod">
-          <ac:chgData name="Shivam Singh" userId="e52e9ba4b5bcdf08" providerId="LiveId" clId="{341AFF7A-C5CD-4491-9020-97A9030EB6ED}" dt="2026-08-15T06:31:48.831" v="1" actId="26606"/>
-          <ac:spMkLst>
-            <pc:docMk/>
-            <pc:sldMk cId="0" sldId="278"/>
-            <ac:spMk id="17" creationId="{00000000-0000-0000-0000-000000000000}"/>
-          </ac:spMkLst>
-        </pc:spChg>
-        <pc:spChg chg="add">
-          <ac:chgData name="Shivam Singh" userId="e52e9ba4b5bcdf08" providerId="LiveId" clId="{341AFF7A-C5CD-4491-9020-97A9030EB6ED}" dt="2026-08-15T06:31:48.831" v="1" actId="26606"/>
-          <ac:spMkLst>
-            <pc:docMk/>
-            <pc:sldMk cId="0" sldId="278"/>
-            <ac:spMk id="20" creationId="{00000000-0000-0000-0000-000000000000}"/>
-          </ac:spMkLst>
-        </pc:spChg>
-        <pc:spChg chg="add mod">
-          <ac:chgData name="Shivam Singh" userId="e52e9ba4b5bcdf08" providerId="LiveId" clId="{341AFF7A-C5CD-4491-9020-97A9030EB6ED}" dt="2026-08-15T06:52:05.400" v="139" actId="26606"/>
-          <ac:spMkLst>
-            <pc:docMk/>
-            <pc:sldMk cId="0" sldId="278"/>
-            <ac:spMk id="21" creationId="{00000000-0000-0000-0000-000000000000}"/>
-          </ac:spMkLst>
-        </pc:spChg>
-        <pc:spChg chg="mod">
-          <ac:chgData name="Shivam Singh" userId="e52e9ba4b5bcdf08" providerId="LiveId" clId="{341AFF7A-C5CD-4491-9020-97A9030EB6ED}" dt="2026-08-15T06:52:05.400" v="139" actId="26606"/>
-          <ac:spMkLst>
-            <pc:docMk/>
-            <pc:sldMk cId="0" sldId="278"/>
-            <ac:spMk id="22" creationId="{00000000-0000-0000-0000-000000000000}"/>
-          </ac:spMkLst>
-        </pc:spChg>
-        <pc:spChg chg="add">
-          <ac:chgData name="Shivam Singh" userId="e52e9ba4b5bcdf08" providerId="LiveId" clId="{341AFF7A-C5CD-4491-9020-97A9030EB6ED}" dt="2026-08-15T06:31:48.831" v="1" actId="26606"/>
-          <ac:spMkLst>
-            <pc:docMk/>
-            <pc:sldMk cId="0" sldId="278"/>
-            <ac:spMk id="26" creationId="{00000000-0000-0000-0000-000000000000}"/>
-          </ac:spMkLst>
-        </pc:spChg>
-        <pc:spChg chg="mod">
-          <ac:chgData name="Shivam Singh" userId="e52e9ba4b5bcdf08" providerId="LiveId" clId="{341AFF7A-C5CD-4491-9020-97A9030EB6ED}" dt="2026-08-15T06:52:05.400" v="139" actId="26606"/>
-          <ac:spMkLst>
-            <pc:docMk/>
-            <pc:sldMk cId="0" sldId="278"/>
-            <ac:spMk id="27" creationId="{00000000-0000-0000-0000-000000000000}"/>
-          </ac:spMkLst>
-        </pc:spChg>
-        <pc:spChg chg="mod">
-          <ac:chgData name="Shivam Singh" userId="e52e9ba4b5bcdf08" providerId="LiveId" clId="{341AFF7A-C5CD-4491-9020-97A9030EB6ED}" dt="2026-08-15T06:52:05.400" v="139" actId="26606"/>
-          <ac:spMkLst>
-            <pc:docMk/>
-            <pc:sldMk cId="0" sldId="278"/>
-            <ac:spMk id="29" creationId="{00000000-0000-0000-0000-000000000000}"/>
-          </ac:spMkLst>
-        </pc:spChg>
-        <pc:spChg chg="add">
-          <ac:chgData name="Shivam Singh" userId="e52e9ba4b5bcdf08" providerId="LiveId" clId="{341AFF7A-C5CD-4491-9020-97A9030EB6ED}" dt="2026-08-15T06:31:48.831" v="1" actId="26606"/>
-          <ac:spMkLst>
-            <pc:docMk/>
-            <pc:sldMk cId="0" sldId="278"/>
-            <ac:spMk id="32" creationId="{00000000-0000-0000-0000-000000000000}"/>
-          </ac:spMkLst>
-        </pc:spChg>
-        <pc:spChg chg="mod">
-          <ac:chgData name="Shivam Singh" userId="e52e9ba4b5bcdf08" providerId="LiveId" clId="{341AFF7A-C5CD-4491-9020-97A9030EB6ED}" dt="2026-08-15T06:52:05.400" v="139" actId="26606"/>
-          <ac:spMkLst>
-            <pc:docMk/>
-            <pc:sldMk cId="0" sldId="278"/>
-            <ac:spMk id="33" creationId="{00000000-0000-0000-0000-000000000000}"/>
-          </ac:spMkLst>
-        </pc:spChg>
-        <pc:spChg chg="mod replId">
-          <ac:chgData name="Shivam Singh" userId="e52e9ba4b5bcdf08" providerId="LiveId" clId="{341AFF7A-C5CD-4491-9020-97A9030EB6ED}" dt="2026-08-15T06:31:47.763" v="0" actId="26606"/>
-          <ac:spMkLst>
-            <pc:docMk/>
-            <pc:sldMk cId="0" sldId="278"/>
-            <ac:spMk id="34" creationId="{00000000-0000-0000-0000-000000000000}"/>
-          </ac:spMkLst>
-        </pc:spChg>
-        <pc:spChg chg="del mod replId">
-          <ac:chgData name="Shivam Singh" userId="e52e9ba4b5bcdf08" providerId="LiveId" clId="{341AFF7A-C5CD-4491-9020-97A9030EB6ED}" dt="2026-08-15T06:31:48.831" v="1" actId="26606"/>
-          <ac:spMkLst>
-            <pc:docMk/>
-            <pc:sldMk cId="0" sldId="278"/>
-            <ac:spMk id="35" creationId="{00000000-0000-0000-0000-000000000000}"/>
-          </ac:spMkLst>
-        </pc:spChg>
-        <pc:spChg chg="del mod replId">
-          <ac:chgData name="Shivam Singh" userId="e52e9ba4b5bcdf08" providerId="LiveId" clId="{341AFF7A-C5CD-4491-9020-97A9030EB6ED}" dt="2026-08-15T06:31:48.831" v="1" actId="26606"/>
-          <ac:spMkLst>
-            <pc:docMk/>
-            <pc:sldMk cId="0" sldId="278"/>
-            <ac:spMk id="36" creationId="{00000000-0000-0000-0000-000000000000}"/>
-          </ac:spMkLst>
-        </pc:spChg>
-        <pc:spChg chg="del mod replId">
-          <ac:chgData name="Shivam Singh" userId="e52e9ba4b5bcdf08" providerId="LiveId" clId="{341AFF7A-C5CD-4491-9020-97A9030EB6ED}" dt="2026-08-15T06:31:48.831" v="1" actId="26606"/>
-          <ac:spMkLst>
-            <pc:docMk/>
-            <pc:sldMk cId="0" sldId="278"/>
-            <ac:spMk id="37" creationId="{00000000-0000-0000-0000-000000000000}"/>
-          </ac:spMkLst>
-        </pc:spChg>
-      </pc:sldChg>
-      <pc:sldChg chg="addSp delSp modSp mod ord setBg">
-        <pc:chgData name="Shivam Singh" userId="e52e9ba4b5bcdf08" providerId="LiveId" clId="{341AFF7A-C5CD-4491-9020-97A9030EB6ED}" dt="2026-08-15T06:52:05.400" v="139" actId="26606"/>
-        <pc:sldMkLst>
-          <pc:docMk/>
-          <pc:sldMk cId="0" sldId="283"/>
-        </pc:sldMkLst>
-        <pc:spChg chg="mod">
-          <ac:chgData name="Shivam Singh" userId="e52e9ba4b5bcdf08" providerId="LiveId" clId="{341AFF7A-C5CD-4491-9020-97A9030EB6ED}" dt="2026-08-15T06:52:05.400" v="139" actId="26606"/>
-          <ac:spMkLst>
-            <pc:docMk/>
-            <pc:sldMk cId="0" sldId="283"/>
-            <ac:spMk id="2" creationId="{00000000-0000-0000-0000-000000000000}"/>
-          </ac:spMkLst>
-        </pc:spChg>
-        <pc:spChg chg="mod">
-          <ac:chgData name="Shivam Singh" userId="e52e9ba4b5bcdf08" providerId="LiveId" clId="{341AFF7A-C5CD-4491-9020-97A9030EB6ED}" dt="2026-08-15T06:52:05.400" v="139" actId="26606"/>
-          <ac:spMkLst>
-            <pc:docMk/>
-            <pc:sldMk cId="0" sldId="283"/>
-            <ac:spMk id="9" creationId="{00000000-0000-0000-0000-000000000000}"/>
-          </ac:spMkLst>
-        </pc:spChg>
-        <pc:spChg chg="mod">
-          <ac:chgData name="Shivam Singh" userId="e52e9ba4b5bcdf08" providerId="LiveId" clId="{341AFF7A-C5CD-4491-9020-97A9030EB6ED}" dt="2026-08-15T06:31:48.831" v="1" actId="26606"/>
-          <ac:spMkLst>
-            <pc:docMk/>
-            <pc:sldMk cId="0" sldId="283"/>
-            <ac:spMk id="10" creationId="{00000000-0000-0000-0000-000000000000}"/>
-          </ac:spMkLst>
-        </pc:spChg>
-        <pc:spChg chg="mod">
-          <ac:chgData name="Shivam Singh" userId="e52e9ba4b5bcdf08" providerId="LiveId" clId="{341AFF7A-C5CD-4491-9020-97A9030EB6ED}" dt="2026-08-15T06:52:05.400" v="139" actId="26606"/>
-          <ac:spMkLst>
-            <pc:docMk/>
-            <pc:sldMk cId="0" sldId="283"/>
-            <ac:spMk id="15" creationId="{00000000-0000-0000-0000-000000000000}"/>
-          </ac:spMkLst>
-        </pc:spChg>
-        <pc:spChg chg="mod">
-          <ac:chgData name="Shivam Singh" userId="e52e9ba4b5bcdf08" providerId="LiveId" clId="{341AFF7A-C5CD-4491-9020-97A9030EB6ED}" dt="2026-08-15T06:52:05.400" v="139" actId="26606"/>
-          <ac:spMkLst>
-            <pc:docMk/>
-            <pc:sldMk cId="0" sldId="283"/>
-            <ac:spMk id="16" creationId="{00000000-0000-0000-0000-000000000000}"/>
-          </ac:spMkLst>
-        </pc:spChg>
-        <pc:spChg chg="mod">
-          <ac:chgData name="Shivam Singh" userId="e52e9ba4b5bcdf08" providerId="LiveId" clId="{341AFF7A-C5CD-4491-9020-97A9030EB6ED}" dt="2026-08-15T06:52:05.400" v="139" actId="26606"/>
-          <ac:spMkLst>
-            <pc:docMk/>
-            <pc:sldMk cId="0" sldId="283"/>
-            <ac:spMk id="21" creationId="{00000000-0000-0000-0000-000000000000}"/>
-          </ac:spMkLst>
-        </pc:spChg>
-        <pc:spChg chg="mod">
-          <ac:chgData name="Shivam Singh" userId="e52e9ba4b5bcdf08" providerId="LiveId" clId="{341AFF7A-C5CD-4491-9020-97A9030EB6ED}" dt="2026-08-15T06:31:48.831" v="1" actId="26606"/>
-          <ac:spMkLst>
-            <pc:docMk/>
-            <pc:sldMk cId="0" sldId="283"/>
-            <ac:spMk id="22" creationId="{00000000-0000-0000-0000-000000000000}"/>
-          </ac:spMkLst>
-        </pc:spChg>
-        <pc:spChg chg="mod">
-          <ac:chgData name="Shivam Singh" userId="e52e9ba4b5bcdf08" providerId="LiveId" clId="{341AFF7A-C5CD-4491-9020-97A9030EB6ED}" dt="2026-08-15T06:45:54.124" v="126" actId="6549"/>
-          <ac:spMkLst>
-            <pc:docMk/>
-            <pc:sldMk cId="0" sldId="283"/>
-            <ac:spMk id="24" creationId="{00000000-0000-0000-0000-000000000000}"/>
-          </ac:spMkLst>
-        </pc:spChg>
-        <pc:spChg chg="mod">
-          <ac:chgData name="Shivam Singh" userId="e52e9ba4b5bcdf08" providerId="LiveId" clId="{341AFF7A-C5CD-4491-9020-97A9030EB6ED}" dt="2026-08-15T06:52:05.400" v="139" actId="26606"/>
-          <ac:spMkLst>
-            <pc:docMk/>
-            <pc:sldMk cId="0" sldId="283"/>
-            <ac:spMk id="28" creationId="{00000000-0000-0000-0000-000000000000}"/>
-          </ac:spMkLst>
-        </pc:spChg>
-        <pc:spChg chg="del">
-          <ac:chgData name="Shivam Singh" userId="e52e9ba4b5bcdf08" providerId="LiveId" clId="{341AFF7A-C5CD-4491-9020-97A9030EB6ED}" dt="2026-08-15T06:31:48.831" v="1" actId="26606"/>
-          <ac:spMkLst>
-            <pc:docMk/>
-            <pc:sldMk cId="0" sldId="283"/>
-            <ac:spMk id="30" creationId="{00000000-0000-0000-0000-000000000000}"/>
-          </ac:spMkLst>
-        </pc:spChg>
-        <pc:spChg chg="del">
-          <ac:chgData name="Shivam Singh" userId="e52e9ba4b5bcdf08" providerId="LiveId" clId="{341AFF7A-C5CD-4491-9020-97A9030EB6ED}" dt="2026-08-15T06:31:48.831" v="1" actId="26606"/>
-          <ac:spMkLst>
-            <pc:docMk/>
-            <pc:sldMk cId="0" sldId="283"/>
-            <ac:spMk id="36" creationId="{00000000-0000-0000-0000-000000000000}"/>
-          </ac:spMkLst>
-        </pc:spChg>
-        <pc:spChg chg="del">
-          <ac:chgData name="Shivam Singh" userId="e52e9ba4b5bcdf08" providerId="LiveId" clId="{341AFF7A-C5CD-4491-9020-97A9030EB6ED}" dt="2026-08-15T06:31:48.831" v="1" actId="26606"/>
-          <ac:spMkLst>
-            <pc:docMk/>
-            <pc:sldMk cId="0" sldId="283"/>
-            <ac:spMk id="38" creationId="{00000000-0000-0000-0000-000000000000}"/>
-          </ac:spMkLst>
-        </pc:spChg>
-        <pc:spChg chg="del">
-          <ac:chgData name="Shivam Singh" userId="e52e9ba4b5bcdf08" providerId="LiveId" clId="{341AFF7A-C5CD-4491-9020-97A9030EB6ED}" dt="2026-08-15T06:31:48.831" v="1" actId="26606"/>
-          <ac:spMkLst>
-            <pc:docMk/>
-            <pc:sldMk cId="0" sldId="283"/>
-            <ac:spMk id="39" creationId="{00000000-0000-0000-0000-000000000000}"/>
-          </ac:spMkLst>
-        </pc:spChg>
-        <pc:spChg chg="del">
-          <ac:chgData name="Shivam Singh" userId="e52e9ba4b5bcdf08" providerId="LiveId" clId="{341AFF7A-C5CD-4491-9020-97A9030EB6ED}" dt="2026-08-15T06:31:48.831" v="1" actId="26606"/>
-          <ac:spMkLst>
-            <pc:docMk/>
-            <pc:sldMk cId="0" sldId="283"/>
-            <ac:spMk id="51" creationId="{00000000-0000-0000-0000-000000000000}"/>
-          </ac:spMkLst>
-        </pc:spChg>
-        <pc:spChg chg="del">
-          <ac:chgData name="Shivam Singh" userId="e52e9ba4b5bcdf08" providerId="LiveId" clId="{341AFF7A-C5CD-4491-9020-97A9030EB6ED}" dt="2026-08-15T06:31:48.831" v="1" actId="26606"/>
-          <ac:spMkLst>
-            <pc:docMk/>
-            <pc:sldMk cId="0" sldId="283"/>
-            <ac:spMk id="59" creationId="{00000000-0000-0000-0000-000000000000}"/>
-          </ac:spMkLst>
-        </pc:spChg>
-        <pc:spChg chg="del mod replId">
-          <ac:chgData name="Shivam Singh" userId="e52e9ba4b5bcdf08" providerId="LiveId" clId="{341AFF7A-C5CD-4491-9020-97A9030EB6ED}" dt="2026-08-15T06:31:48.831" v="1" actId="26606"/>
-          <ac:spMkLst>
-            <pc:docMk/>
-            <pc:sldMk cId="0" sldId="283"/>
-            <ac:spMk id="61" creationId="{00000000-0000-0000-0000-000000000000}"/>
-          </ac:spMkLst>
-        </pc:spChg>
-        <pc:spChg chg="mod replId">
-          <ac:chgData name="Shivam Singh" userId="e52e9ba4b5bcdf08" providerId="LiveId" clId="{341AFF7A-C5CD-4491-9020-97A9030EB6ED}" dt="2026-08-15T06:31:47.763" v="0" actId="26606"/>
-          <ac:spMkLst>
-            <pc:docMk/>
-            <pc:sldMk cId="0" sldId="283"/>
-            <ac:spMk id="63" creationId="{00000000-0000-0000-0000-000000000000}"/>
-          </ac:spMkLst>
-        </pc:spChg>
-        <pc:spChg chg="mod replId">
-          <ac:chgData name="Shivam Singh" userId="e52e9ba4b5bcdf08" providerId="LiveId" clId="{341AFF7A-C5CD-4491-9020-97A9030EB6ED}" dt="2026-08-15T06:31:47.763" v="0" actId="26606"/>
-          <ac:spMkLst>
-            <pc:docMk/>
-            <pc:sldMk cId="0" sldId="283"/>
-            <ac:spMk id="64" creationId="{00000000-0000-0000-0000-000000000000}"/>
-          </ac:spMkLst>
-        </pc:spChg>
-        <pc:spChg chg="mod replId">
-          <ac:chgData name="Shivam Singh" userId="e52e9ba4b5bcdf08" providerId="LiveId" clId="{341AFF7A-C5CD-4491-9020-97A9030EB6ED}" dt="2026-08-15T06:31:47.763" v="0" actId="26606"/>
-          <ac:spMkLst>
-            <pc:docMk/>
-            <pc:sldMk cId="0" sldId="283"/>
-            <ac:spMk id="65" creationId="{00000000-0000-0000-0000-000000000000}"/>
-          </ac:spMkLst>
-        </pc:spChg>
-      </pc:sldChg>
-      <pc:sldChg chg="addSp delSp modSp mod setBg">
-        <pc:chgData name="Shivam Singh" userId="e52e9ba4b5bcdf08" providerId="LiveId" clId="{341AFF7A-C5CD-4491-9020-97A9030EB6ED}" dt="2026-08-15T06:52:05.400" v="139" actId="26606"/>
-        <pc:sldMkLst>
-          <pc:docMk/>
-          <pc:sldMk cId="0" sldId="284"/>
-        </pc:sldMkLst>
-        <pc:spChg chg="mod">
-          <ac:chgData name="Shivam Singh" userId="e52e9ba4b5bcdf08" providerId="LiveId" clId="{341AFF7A-C5CD-4491-9020-97A9030EB6ED}" dt="2026-08-15T06:31:48.831" v="1" actId="26606"/>
-          <ac:spMkLst>
-            <pc:docMk/>
-            <pc:sldMk cId="0" sldId="284"/>
-            <ac:spMk id="7" creationId="{00000000-0000-0000-0000-000000000000}"/>
-          </ac:spMkLst>
-        </pc:spChg>
-        <pc:spChg chg="mod">
-          <ac:chgData name="Shivam Singh" userId="e52e9ba4b5bcdf08" providerId="LiveId" clId="{341AFF7A-C5CD-4491-9020-97A9030EB6ED}" dt="2026-08-15T06:31:48.831" v="1" actId="26606"/>
-          <ac:spMkLst>
-            <pc:docMk/>
-            <pc:sldMk cId="0" sldId="284"/>
-            <ac:spMk id="8" creationId="{00000000-0000-0000-0000-000000000000}"/>
-          </ac:spMkLst>
-        </pc:spChg>
-        <pc:spChg chg="mod">
-          <ac:chgData name="Shivam Singh" userId="e52e9ba4b5bcdf08" providerId="LiveId" clId="{341AFF7A-C5CD-4491-9020-97A9030EB6ED}" dt="2026-08-15T06:31:48.831" v="1" actId="26606"/>
-          <ac:spMkLst>
-            <pc:docMk/>
-            <pc:sldMk cId="0" sldId="284"/>
-            <ac:spMk id="9" creationId="{00000000-0000-0000-0000-000000000000}"/>
-          </ac:spMkLst>
-        </pc:spChg>
-        <pc:spChg chg="mod">
-          <ac:chgData name="Shivam Singh" userId="e52e9ba4b5bcdf08" providerId="LiveId" clId="{341AFF7A-C5CD-4491-9020-97A9030EB6ED}" dt="2026-08-15T06:31:48.831" v="1" actId="26606"/>
-          <ac:spMkLst>
-            <pc:docMk/>
-            <pc:sldMk cId="0" sldId="284"/>
-            <ac:spMk id="12" creationId="{00000000-0000-0000-0000-000000000000}"/>
-          </ac:spMkLst>
-        </pc:spChg>
-        <pc:spChg chg="mod">
-          <ac:chgData name="Shivam Singh" userId="e52e9ba4b5bcdf08" providerId="LiveId" clId="{341AFF7A-C5CD-4491-9020-97A9030EB6ED}" dt="2026-08-15T06:31:48.831" v="1" actId="26606"/>
-          <ac:spMkLst>
-            <pc:docMk/>
-            <pc:sldMk cId="0" sldId="284"/>
-            <ac:spMk id="13" creationId="{00000000-0000-0000-0000-000000000000}"/>
-          </ac:spMkLst>
-        </pc:spChg>
-        <pc:spChg chg="mod">
-          <ac:chgData name="Shivam Singh" userId="e52e9ba4b5bcdf08" providerId="LiveId" clId="{341AFF7A-C5CD-4491-9020-97A9030EB6ED}" dt="2026-08-15T06:52:05.400" v="139" actId="26606"/>
-          <ac:spMkLst>
-            <pc:docMk/>
-            <pc:sldMk cId="0" sldId="284"/>
-            <ac:spMk id="25" creationId="{00000000-0000-0000-0000-000000000000}"/>
-          </ac:spMkLst>
-        </pc:spChg>
-        <pc:spChg chg="mod">
-          <ac:chgData name="Shivam Singh" userId="e52e9ba4b5bcdf08" providerId="LiveId" clId="{341AFF7A-C5CD-4491-9020-97A9030EB6ED}" dt="2026-08-15T06:52:05.400" v="139" actId="26606"/>
-          <ac:spMkLst>
-            <pc:docMk/>
-            <pc:sldMk cId="0" sldId="284"/>
-            <ac:spMk id="26" creationId="{00000000-0000-0000-0000-000000000000}"/>
-          </ac:spMkLst>
-        </pc:spChg>
-        <pc:spChg chg="del">
-          <ac:chgData name="Shivam Singh" userId="e52e9ba4b5bcdf08" providerId="LiveId" clId="{341AFF7A-C5CD-4491-9020-97A9030EB6ED}" dt="2026-08-15T06:31:48.831" v="1" actId="26606"/>
-          <ac:spMkLst>
-            <pc:docMk/>
-            <pc:sldMk cId="0" sldId="284"/>
-            <ac:spMk id="27" creationId="{00000000-0000-0000-0000-000000000000}"/>
-          </ac:spMkLst>
-        </pc:spChg>
-        <pc:spChg chg="del">
-          <ac:chgData name="Shivam Singh" userId="e52e9ba4b5bcdf08" providerId="LiveId" clId="{341AFF7A-C5CD-4491-9020-97A9030EB6ED}" dt="2026-08-15T06:31:48.831" v="1" actId="26606"/>
-          <ac:spMkLst>
-            <pc:docMk/>
-            <pc:sldMk cId="0" sldId="284"/>
-            <ac:spMk id="30" creationId="{00000000-0000-0000-0000-000000000000}"/>
-          </ac:spMkLst>
-        </pc:spChg>
-        <pc:spChg chg="del">
-          <ac:chgData name="Shivam Singh" userId="e52e9ba4b5bcdf08" providerId="LiveId" clId="{341AFF7A-C5CD-4491-9020-97A9030EB6ED}" dt="2026-08-15T06:31:48.831" v="1" actId="26606"/>
-          <ac:spMkLst>
-            <pc:docMk/>
-            <pc:sldMk cId="0" sldId="284"/>
-            <ac:spMk id="31" creationId="{00000000-0000-0000-0000-000000000000}"/>
-          </ac:spMkLst>
-        </pc:spChg>
-        <pc:spChg chg="del">
-          <ac:chgData name="Shivam Singh" userId="e52e9ba4b5bcdf08" providerId="LiveId" clId="{341AFF7A-C5CD-4491-9020-97A9030EB6ED}" dt="2026-08-15T06:31:48.831" v="1" actId="26606"/>
-          <ac:spMkLst>
-            <pc:docMk/>
-            <pc:sldMk cId="0" sldId="284"/>
-            <ac:spMk id="33" creationId="{00000000-0000-0000-0000-000000000000}"/>
-          </ac:spMkLst>
-        </pc:spChg>
-        <pc:spChg chg="del">
-          <ac:chgData name="Shivam Singh" userId="e52e9ba4b5bcdf08" providerId="LiveId" clId="{341AFF7A-C5CD-4491-9020-97A9030EB6ED}" dt="2026-08-15T06:31:48.831" v="1" actId="26606"/>
-          <ac:spMkLst>
-            <pc:docMk/>
-            <pc:sldMk cId="0" sldId="284"/>
-            <ac:spMk id="35" creationId="{00000000-0000-0000-0000-000000000000}"/>
-          </ac:spMkLst>
-        </pc:spChg>
-        <pc:spChg chg="mod replId">
-          <ac:chgData name="Shivam Singh" userId="e52e9ba4b5bcdf08" providerId="LiveId" clId="{341AFF7A-C5CD-4491-9020-97A9030EB6ED}" dt="2026-08-15T06:31:47.763" v="0" actId="26606"/>
-          <ac:spMkLst>
-            <pc:docMk/>
-            <pc:sldMk cId="0" sldId="284"/>
-            <ac:spMk id="40" creationId="{00000000-0000-0000-0000-000000000000}"/>
-          </ac:spMkLst>
-        </pc:spChg>
-        <pc:spChg chg="mod replId">
-          <ac:chgData name="Shivam Singh" userId="e52e9ba4b5bcdf08" providerId="LiveId" clId="{341AFF7A-C5CD-4491-9020-97A9030EB6ED}" dt="2026-08-15T06:31:47.763" v="0" actId="26606"/>
-          <ac:spMkLst>
-            <pc:docMk/>
-            <pc:sldMk cId="0" sldId="284"/>
-            <ac:spMk id="41" creationId="{00000000-0000-0000-0000-000000000000}"/>
-          </ac:spMkLst>
-        </pc:spChg>
-        <pc:spChg chg="mod replId">
-          <ac:chgData name="Shivam Singh" userId="e52e9ba4b5bcdf08" providerId="LiveId" clId="{341AFF7A-C5CD-4491-9020-97A9030EB6ED}" dt="2026-08-15T06:31:47.763" v="0" actId="26606"/>
-          <ac:spMkLst>
-            <pc:docMk/>
-            <pc:sldMk cId="0" sldId="284"/>
-            <ac:spMk id="42" creationId="{00000000-0000-0000-0000-000000000000}"/>
-          </ac:spMkLst>
-        </pc:spChg>
-      </pc:sldChg>
-      <pc:sldChg chg="addSp delSp modSp mod ord setBg">
-        <pc:chgData name="Shivam Singh" userId="e52e9ba4b5bcdf08" providerId="LiveId" clId="{341AFF7A-C5CD-4491-9020-97A9030EB6ED}" dt="2026-08-15T06:52:05.400" v="139" actId="26606"/>
-        <pc:sldMkLst>
-          <pc:docMk/>
-          <pc:sldMk cId="0" sldId="285"/>
-        </pc:sldMkLst>
-        <pc:spChg chg="mod">
-          <ac:chgData name="Shivam Singh" userId="e52e9ba4b5bcdf08" providerId="LiveId" clId="{341AFF7A-C5CD-4491-9020-97A9030EB6ED}" dt="2026-08-15T06:49:17.314" v="137" actId="20577"/>
-          <ac:spMkLst>
-            <pc:docMk/>
-            <pc:sldMk cId="0" sldId="285"/>
-            <ac:spMk id="2" creationId="{00000000-0000-0000-0000-000000000000}"/>
-          </ac:spMkLst>
-        </pc:spChg>
-        <pc:spChg chg="mod">
-          <ac:chgData name="Shivam Singh" userId="e52e9ba4b5bcdf08" providerId="LiveId" clId="{341AFF7A-C5CD-4491-9020-97A9030EB6ED}" dt="2026-08-15T06:31:48.831" v="1" actId="26606"/>
-          <ac:spMkLst>
-            <pc:docMk/>
-            <pc:sldMk cId="0" sldId="285"/>
-            <ac:spMk id="8" creationId="{00000000-0000-0000-0000-000000000000}"/>
-          </ac:spMkLst>
-        </pc:spChg>
-        <pc:spChg chg="mod">
-          <ac:chgData name="Shivam Singh" userId="e52e9ba4b5bcdf08" providerId="LiveId" clId="{341AFF7A-C5CD-4491-9020-97A9030EB6ED}" dt="2026-08-15T06:31:48.831" v="1" actId="26606"/>
-          <ac:spMkLst>
-            <pc:docMk/>
-            <pc:sldMk cId="0" sldId="285"/>
-            <ac:spMk id="12" creationId="{00000000-0000-0000-0000-000000000000}"/>
-          </ac:spMkLst>
-        </pc:spChg>
-        <pc:spChg chg="mod">
-          <ac:chgData name="Shivam Singh" userId="e52e9ba4b5bcdf08" providerId="LiveId" clId="{341AFF7A-C5CD-4491-9020-97A9030EB6ED}" dt="2026-08-15T06:31:48.831" v="1" actId="26606"/>
-          <ac:spMkLst>
-            <pc:docMk/>
-            <pc:sldMk cId="0" sldId="285"/>
-            <ac:spMk id="15" creationId="{00000000-0000-0000-0000-000000000000}"/>
-          </ac:spMkLst>
-        </pc:spChg>
-        <pc:spChg chg="mod">
-          <ac:chgData name="Shivam Singh" userId="e52e9ba4b5bcdf08" providerId="LiveId" clId="{341AFF7A-C5CD-4491-9020-97A9030EB6ED}" dt="2026-08-15T06:52:05.400" v="139" actId="26606"/>
-          <ac:spMkLst>
-            <pc:docMk/>
-            <pc:sldMk cId="0" sldId="285"/>
-            <ac:spMk id="16" creationId="{00000000-0000-0000-0000-000000000000}"/>
-          </ac:spMkLst>
-        </pc:spChg>
-        <pc:spChg chg="mod">
-          <ac:chgData name="Shivam Singh" userId="e52e9ba4b5bcdf08" providerId="LiveId" clId="{341AFF7A-C5CD-4491-9020-97A9030EB6ED}" dt="2026-08-15T06:31:48.831" v="1" actId="26606"/>
-          <ac:spMkLst>
-            <pc:docMk/>
-            <pc:sldMk cId="0" sldId="285"/>
-            <ac:spMk id="17" creationId="{00000000-0000-0000-0000-000000000000}"/>
-          </ac:spMkLst>
-        </pc:spChg>
-        <pc:spChg chg="mod">
-          <ac:chgData name="Shivam Singh" userId="e52e9ba4b5bcdf08" providerId="LiveId" clId="{341AFF7A-C5CD-4491-9020-97A9030EB6ED}" dt="2026-08-15T06:31:48.831" v="1" actId="26606"/>
-          <ac:spMkLst>
-            <pc:docMk/>
-            <pc:sldMk cId="0" sldId="285"/>
-            <ac:spMk id="19" creationId="{00000000-0000-0000-0000-000000000000}"/>
-          </ac:spMkLst>
-        </pc:spChg>
-        <pc:spChg chg="mod">
-          <ac:chgData name="Shivam Singh" userId="e52e9ba4b5bcdf08" providerId="LiveId" clId="{341AFF7A-C5CD-4491-9020-97A9030EB6ED}" dt="2026-08-15T06:31:48.831" v="1" actId="26606"/>
-          <ac:spMkLst>
-            <pc:docMk/>
-            <pc:sldMk cId="0" sldId="285"/>
-            <ac:spMk id="22" creationId="{00000000-0000-0000-0000-000000000000}"/>
-          </ac:spMkLst>
-        </pc:spChg>
-        <pc:spChg chg="mod">
-          <ac:chgData name="Shivam Singh" userId="e52e9ba4b5bcdf08" providerId="LiveId" clId="{341AFF7A-C5CD-4491-9020-97A9030EB6ED}" dt="2026-08-15T06:31:48.831" v="1" actId="26606"/>
-          <ac:spMkLst>
-            <pc:docMk/>
-            <pc:sldMk cId="0" sldId="285"/>
-            <ac:spMk id="26" creationId="{00000000-0000-0000-0000-000000000000}"/>
-          </ac:spMkLst>
-        </pc:spChg>
-        <pc:spChg chg="add">
-          <ac:chgData name="Shivam Singh" userId="e52e9ba4b5bcdf08" providerId="LiveId" clId="{341AFF7A-C5CD-4491-9020-97A9030EB6ED}" dt="2026-08-15T06:31:48.831" v="1" actId="26606"/>
-          <ac:spMkLst>
-            <pc:docMk/>
-            <pc:sldMk cId="0" sldId="285"/>
-            <ac:spMk id="30" creationId="{00000000-0000-0000-0000-000000000000}"/>
-          </ac:spMkLst>
-        </pc:spChg>
-        <pc:spChg chg="mod">
-          <ac:chgData name="Shivam Singh" userId="e52e9ba4b5bcdf08" providerId="LiveId" clId="{341AFF7A-C5CD-4491-9020-97A9030EB6ED}" dt="2026-08-15T06:31:48.831" v="1" actId="26606"/>
-          <ac:spMkLst>
-            <pc:docMk/>
-            <pc:sldMk cId="0" sldId="285"/>
-            <ac:spMk id="32" creationId="{00000000-0000-0000-0000-000000000000}"/>
-          </ac:spMkLst>
-        </pc:spChg>
-        <pc:spChg chg="mod">
-          <ac:chgData name="Shivam Singh" userId="e52e9ba4b5bcdf08" providerId="LiveId" clId="{341AFF7A-C5CD-4491-9020-97A9030EB6ED}" dt="2026-08-15T06:52:05.400" v="139" actId="26606"/>
-          <ac:spMkLst>
-            <pc:docMk/>
-            <pc:sldMk cId="0" sldId="285"/>
-            <ac:spMk id="35" creationId="{00000000-0000-0000-0000-000000000000}"/>
-          </ac:spMkLst>
-        </pc:spChg>
-        <pc:spChg chg="mod">
-          <ac:chgData name="Shivam Singh" userId="e52e9ba4b5bcdf08" providerId="LiveId" clId="{341AFF7A-C5CD-4491-9020-97A9030EB6ED}" dt="2026-08-15T06:52:05.400" v="139" actId="26606"/>
-          <ac:spMkLst>
-            <pc:docMk/>
-            <pc:sldMk cId="0" sldId="285"/>
-            <ac:spMk id="38" creationId="{00000000-0000-0000-0000-000000000000}"/>
-          </ac:spMkLst>
-        </pc:spChg>
-        <pc:spChg chg="mod replId">
-          <ac:chgData name="Shivam Singh" userId="e52e9ba4b5bcdf08" providerId="LiveId" clId="{341AFF7A-C5CD-4491-9020-97A9030EB6ED}" dt="2026-08-15T06:31:47.763" v="0" actId="26606"/>
-          <ac:spMkLst>
-            <pc:docMk/>
-            <pc:sldMk cId="0" sldId="285"/>
-            <ac:spMk id="39" creationId="{00000000-0000-0000-0000-000000000000}"/>
-          </ac:spMkLst>
-        </pc:spChg>
-        <pc:spChg chg="del mod replId">
-          <ac:chgData name="Shivam Singh" userId="e52e9ba4b5bcdf08" providerId="LiveId" clId="{341AFF7A-C5CD-4491-9020-97A9030EB6ED}" dt="2026-08-15T06:31:48.831" v="1" actId="26606"/>
-          <ac:spMkLst>
-            <pc:docMk/>
-            <pc:sldMk cId="0" sldId="285"/>
-            <ac:spMk id="40" creationId="{00000000-0000-0000-0000-000000000000}"/>
-          </ac:spMkLst>
-        </pc:spChg>
-        <pc:picChg chg="mod replId">
-          <ac:chgData name="Shivam Singh" userId="e52e9ba4b5bcdf08" providerId="LiveId" clId="{341AFF7A-C5CD-4491-9020-97A9030EB6ED}" dt="2026-08-15T06:31:47.763" v="0" actId="26606"/>
-          <ac:picMkLst>
-            <pc:docMk/>
-            <pc:sldMk cId="0" sldId="285"/>
-            <ac:picMk id="41" creationId="{00000000-0000-0000-0000-000000000000}"/>
-          </ac:picMkLst>
-        </pc:picChg>
-        <pc:picChg chg="mod replId">
-          <ac:chgData name="Shivam Singh" userId="e52e9ba4b5bcdf08" providerId="LiveId" clId="{341AFF7A-C5CD-4491-9020-97A9030EB6ED}" dt="2026-08-15T06:31:47.763" v="0" actId="26606"/>
-          <ac:picMkLst>
-            <pc:docMk/>
-            <pc:sldMk cId="0" sldId="285"/>
-            <ac:picMk id="42" creationId="{00000000-0000-0000-0000-000000000000}"/>
-          </ac:picMkLst>
-        </pc:picChg>
-      </pc:sldChg>
-      <pc:sldChg chg="addSp delSp modSp mod ord setBg">
-        <pc:chgData name="Shivam Singh" userId="e52e9ba4b5bcdf08" providerId="LiveId" clId="{341AFF7A-C5CD-4491-9020-97A9030EB6ED}" dt="2026-08-15T06:52:05.400" v="139" actId="26606"/>
-        <pc:sldMkLst>
-          <pc:docMk/>
-          <pc:sldMk cId="0" sldId="286"/>
-        </pc:sldMkLst>
-        <pc:spChg chg="mod">
-          <ac:chgData name="Shivam Singh" userId="e52e9ba4b5bcdf08" providerId="LiveId" clId="{341AFF7A-C5CD-4491-9020-97A9030EB6ED}" dt="2026-08-15T06:52:05.400" v="139" actId="26606"/>
-          <ac:spMkLst>
-            <pc:docMk/>
-            <pc:sldMk cId="0" sldId="286"/>
-            <ac:spMk id="2" creationId="{00000000-0000-0000-0000-000000000000}"/>
-          </ac:spMkLst>
-        </pc:spChg>
-        <pc:spChg chg="mod">
-          <ac:chgData name="Shivam Singh" userId="e52e9ba4b5bcdf08" providerId="LiveId" clId="{341AFF7A-C5CD-4491-9020-97A9030EB6ED}" dt="2026-08-15T06:31:48.831" v="1" actId="26606"/>
-          <ac:spMkLst>
-            <pc:docMk/>
-            <pc:sldMk cId="0" sldId="286"/>
-            <ac:spMk id="4" creationId="{00000000-0000-0000-0000-000000000000}"/>
-          </ac:spMkLst>
-        </pc:spChg>
-        <pc:spChg chg="mod">
-          <ac:chgData name="Shivam Singh" userId="e52e9ba4b5bcdf08" providerId="LiveId" clId="{341AFF7A-C5CD-4491-9020-97A9030EB6ED}" dt="2026-08-15T06:31:48.831" v="1" actId="26606"/>
-          <ac:spMkLst>
-            <pc:docMk/>
-            <pc:sldMk cId="0" sldId="286"/>
-            <ac:spMk id="6" creationId="{00000000-0000-0000-0000-000000000000}"/>
-          </ac:spMkLst>
-        </pc:spChg>
-        <pc:spChg chg="mod">
-          <ac:chgData name="Shivam Singh" userId="e52e9ba4b5bcdf08" providerId="LiveId" clId="{341AFF7A-C5CD-4491-9020-97A9030EB6ED}" dt="2026-08-15T06:31:48.831" v="1" actId="26606"/>
-          <ac:spMkLst>
-            <pc:docMk/>
-            <pc:sldMk cId="0" sldId="286"/>
-            <ac:spMk id="7" creationId="{00000000-0000-0000-0000-000000000000}"/>
-          </ac:spMkLst>
-        </pc:spChg>
-        <pc:spChg chg="mod">
-          <ac:chgData name="Shivam Singh" userId="e52e9ba4b5bcdf08" providerId="LiveId" clId="{341AFF7A-C5CD-4491-9020-97A9030EB6ED}" dt="2026-08-15T06:31:48.831" v="1" actId="26606"/>
-          <ac:spMkLst>
-            <pc:docMk/>
-            <pc:sldMk cId="0" sldId="286"/>
-            <ac:spMk id="10" creationId="{00000000-0000-0000-0000-000000000000}"/>
-          </ac:spMkLst>
-        </pc:spChg>
-        <pc:spChg chg="mod">
-          <ac:chgData name="Shivam Singh" userId="e52e9ba4b5bcdf08" providerId="LiveId" clId="{341AFF7A-C5CD-4491-9020-97A9030EB6ED}" dt="2026-08-15T06:31:48.831" v="1" actId="26606"/>
-          <ac:spMkLst>
-            <pc:docMk/>
-            <pc:sldMk cId="0" sldId="286"/>
-            <ac:spMk id="13" creationId="{00000000-0000-0000-0000-000000000000}"/>
-          </ac:spMkLst>
-        </pc:spChg>
-        <pc:spChg chg="mod">
-          <ac:chgData name="Shivam Singh" userId="e52e9ba4b5bcdf08" providerId="LiveId" clId="{341AFF7A-C5CD-4491-9020-97A9030EB6ED}" dt="2026-08-15T06:31:48.831" v="1" actId="26606"/>
-          <ac:spMkLst>
-            <pc:docMk/>
-            <pc:sldMk cId="0" sldId="286"/>
-            <ac:spMk id="14" creationId="{00000000-0000-0000-0000-000000000000}"/>
-          </ac:spMkLst>
-        </pc:spChg>
-        <pc:spChg chg="mod">
-          <ac:chgData name="Shivam Singh" userId="e52e9ba4b5bcdf08" providerId="LiveId" clId="{341AFF7A-C5CD-4491-9020-97A9030EB6ED}" dt="2026-08-15T06:31:48.831" v="1" actId="26606"/>
-          <ac:spMkLst>
-            <pc:docMk/>
-            <pc:sldMk cId="0" sldId="286"/>
-            <ac:spMk id="18" creationId="{00000000-0000-0000-0000-000000000000}"/>
-          </ac:spMkLst>
-        </pc:spChg>
-        <pc:spChg chg="add del">
-          <ac:chgData name="Shivam Singh" userId="e52e9ba4b5bcdf08" providerId="LiveId" clId="{341AFF7A-C5CD-4491-9020-97A9030EB6ED}" dt="2026-08-15T06:52:05.400" v="139" actId="26606"/>
-          <ac:spMkLst>
-            <pc:docMk/>
-            <pc:sldMk cId="0" sldId="286"/>
-            <ac:spMk id="19" creationId="{00000000-0000-0000-0000-000000000000}"/>
-          </ac:spMkLst>
-        </pc:spChg>
-        <pc:spChg chg="add del">
-          <ac:chgData name="Shivam Singh" userId="e52e9ba4b5bcdf08" providerId="LiveId" clId="{341AFF7A-C5CD-4491-9020-97A9030EB6ED}" dt="2026-08-15T06:52:05.400" v="139" actId="26606"/>
-          <ac:spMkLst>
-            <pc:docMk/>
-            <pc:sldMk cId="0" sldId="286"/>
-            <ac:spMk id="20" creationId="{00000000-0000-0000-0000-000000000000}"/>
-          </ac:spMkLst>
-        </pc:spChg>
-        <pc:spChg chg="del">
-          <ac:chgData name="Shivam Singh" userId="e52e9ba4b5bcdf08" providerId="LiveId" clId="{341AFF7A-C5CD-4491-9020-97A9030EB6ED}" dt="2026-08-15T06:44:00.202" v="117" actId="478"/>
-          <ac:spMkLst>
-            <pc:docMk/>
-            <pc:sldMk cId="0" sldId="286"/>
-            <ac:spMk id="22" creationId="{00000000-0000-0000-0000-000000000000}"/>
-          </ac:spMkLst>
-        </pc:spChg>
-        <pc:spChg chg="add del mod">
-          <ac:chgData name="Shivam Singh" userId="e52e9ba4b5bcdf08" providerId="LiveId" clId="{341AFF7A-C5CD-4491-9020-97A9030EB6ED}" dt="2026-08-15T06:44:05.911" v="120" actId="478"/>
-          <ac:spMkLst>
-            <pc:docMk/>
-            <pc:sldMk cId="0" sldId="286"/>
-            <ac:spMk id="23" creationId="{00000000-0000-0000-0000-000000000000}"/>
-          </ac:spMkLst>
-        </pc:spChg>
-        <pc:spChg chg="mod replId">
-          <ac:chgData name="Shivam Singh" userId="e52e9ba4b5bcdf08" providerId="LiveId" clId="{341AFF7A-C5CD-4491-9020-97A9030EB6ED}" dt="2026-08-15T06:31:47.763" v="0" actId="26606"/>
-          <ac:spMkLst>
-            <pc:docMk/>
-            <pc:sldMk cId="0" sldId="286"/>
-            <ac:spMk id="26" creationId="{00000000-0000-0000-0000-000000000000}"/>
-          </ac:spMkLst>
-        </pc:spChg>
-        <pc:spChg chg="mod replId">
-          <ac:chgData name="Shivam Singh" userId="e52e9ba4b5bcdf08" providerId="LiveId" clId="{341AFF7A-C5CD-4491-9020-97A9030EB6ED}" dt="2026-08-15T06:31:47.763" v="0" actId="26606"/>
-          <ac:spMkLst>
-            <pc:docMk/>
-            <pc:sldMk cId="0" sldId="286"/>
-            <ac:spMk id="27" creationId="{00000000-0000-0000-0000-000000000000}"/>
-          </ac:spMkLst>
-        </pc:spChg>
-        <pc:spChg chg="del mod replId">
-          <ac:chgData name="Shivam Singh" userId="e52e9ba4b5bcdf08" providerId="LiveId" clId="{341AFF7A-C5CD-4491-9020-97A9030EB6ED}" dt="2026-08-15T06:31:48.831" v="1" actId="26606"/>
-          <ac:spMkLst>
-            <pc:docMk/>
-            <pc:sldMk cId="0" sldId="286"/>
-            <ac:spMk id="28" creationId="{00000000-0000-0000-0000-000000000000}"/>
-          </ac:spMkLst>
-        </pc:spChg>
-        <pc:picChg chg="mod replId">
-          <ac:chgData name="Shivam Singh" userId="e52e9ba4b5bcdf08" providerId="LiveId" clId="{341AFF7A-C5CD-4491-9020-97A9030EB6ED}" dt="2026-08-15T06:31:47.763" v="0" actId="26606"/>
-          <ac:picMkLst>
-            <pc:docMk/>
-            <pc:sldMk cId="0" sldId="286"/>
-            <ac:picMk id="29" creationId="{00000000-0000-0000-0000-000000000000}"/>
-          </ac:picMkLst>
-        </pc:picChg>
-        <pc:cxnChg chg="del">
-          <ac:chgData name="Shivam Singh" userId="e52e9ba4b5bcdf08" providerId="LiveId" clId="{341AFF7A-C5CD-4491-9020-97A9030EB6ED}" dt="2026-08-15T06:44:01.708" v="118" actId="478"/>
-          <ac:cxnSpMkLst>
-            <pc:docMk/>
-            <pc:sldMk cId="0" sldId="286"/>
-            <ac:cxnSpMk id="21" creationId="{00000000-0000-0000-0000-000000000000}"/>
-          </ac:cxnSpMkLst>
-        </pc:cxnChg>
-      </pc:sldChg>
-    </pc:docChg>
-  </pc:docChgLst>
-</pc:chgInfo>
 </file>
 
 <file path=ppt/charts/chart1.xml><?xml version="1.0" encoding="utf-8"?>

</xml_diff>